<commit_message>
fix: auto-navigate to console on tour simulations, refine navbar layout, and update pitch deck to executive light theme
</commit_message>
<xml_diff>
--- a/TrustState_Executive_Presentation.pptx
+++ b/TrustState_Executive_Presentation.pptx
@@ -3110,7 +3110,7 @@
             <a:avLst/>
           </a:prstGeom>
           <a:solidFill>
-            <a:srgbClr val="0B1120"/>
+            <a:srgbClr val="F8FAFC"/>
           </a:solidFill>
           <a:ln>
             <a:noFill/>
@@ -3146,18 +3146,18 @@
         </p:nvSpPr>
         <p:spPr>
           <a:xfrm>
-            <a:off x="731520" y="914400"/>
-            <a:ext cx="4114800" cy="411480"/>
+            <a:off x="731520" y="822960"/>
+            <a:ext cx="4389120" cy="411480"/>
           </a:xfrm>
           <a:prstGeom prst="roundRect">
             <a:avLst/>
           </a:prstGeom>
           <a:solidFill>
-            <a:srgbClr val="0C2D23"/>
+            <a:srgbClr val="ECFDF5"/>
           </a:solidFill>
           <a:ln w="12700">
             <a:solidFill>
-              <a:srgbClr val="10B981"/>
+              <a:srgbClr val="059669"/>
             </a:solidFill>
           </a:ln>
         </p:spPr>
@@ -3191,8 +3191,8 @@
         </p:nvSpPr>
         <p:spPr>
           <a:xfrm>
-            <a:off x="731520" y="914400"/>
-            <a:ext cx="4114800" cy="411480"/>
+            <a:off x="731520" y="822960"/>
+            <a:ext cx="4389120" cy="411480"/>
           </a:xfrm>
           <a:prstGeom prst="rect">
             <a:avLst/>
@@ -3208,7 +3208,7 @@
             <a:pPr algn="ctr">
               <a:defRPr sz="1000" b="1">
                 <a:solidFill>
-                  <a:srgbClr val="10B981"/>
+                  <a:srgbClr val="059669"/>
                 </a:solidFill>
               </a:defRPr>
             </a:pPr>
@@ -3226,8 +3226,8 @@
         </p:nvSpPr>
         <p:spPr>
           <a:xfrm>
-            <a:off x="731520" y="1371600"/>
-            <a:ext cx="6217920" cy="1097280"/>
+            <a:off x="731520" y="1280160"/>
+            <a:ext cx="6217920" cy="1005840"/>
           </a:xfrm>
           <a:prstGeom prst="rect">
             <a:avLst/>
@@ -3243,7 +3243,7 @@
             <a:pPr>
               <a:defRPr sz="4600" b="1">
                 <a:solidFill>
-                  <a:srgbClr val="F8FAFC"/>
+                  <a:srgbClr val="0F172A"/>
                 </a:solidFill>
               </a:defRPr>
             </a:pPr>
@@ -3261,8 +3261,8 @@
         </p:nvSpPr>
         <p:spPr>
           <a:xfrm>
-            <a:off x="731520" y="2468880"/>
-            <a:ext cx="6217920" cy="1097280"/>
+            <a:off x="731520" y="2331720"/>
+            <a:ext cx="6217920" cy="1188720"/>
           </a:xfrm>
           <a:prstGeom prst="rect">
             <a:avLst/>
@@ -3278,7 +3278,7 @@
             <a:pPr>
               <a:defRPr sz="2400" b="1">
                 <a:solidFill>
-                  <a:srgbClr val="F8FAFC"/>
+                  <a:srgbClr val="0F172A"/>
                 </a:solidFill>
               </a:defRPr>
             </a:pPr>
@@ -3288,9 +3288,9 @@
           </a:p>
           <a:p>
             <a:pPr>
-              <a:defRPr sz="2000" b="1">
-                <a:solidFill>
-                  <a:srgbClr val="06B6D4"/>
+              <a:defRPr sz="1900" b="1">
+                <a:solidFill>
+                  <a:srgbClr val="0284C7"/>
                 </a:solidFill>
               </a:defRPr>
             </a:pPr>
@@ -3308,8 +3308,8 @@
         </p:nvSpPr>
         <p:spPr>
           <a:xfrm>
-            <a:off x="731520" y="3657600"/>
-            <a:ext cx="6217920" cy="1371600"/>
+            <a:off x="731520" y="3611880"/>
+            <a:ext cx="6217920" cy="1188720"/>
           </a:xfrm>
           <a:prstGeom prst="rect">
             <a:avLst/>
@@ -3323,9 +3323,9 @@
           <a:lstStyle/>
           <a:p>
             <a:pPr>
-              <a:defRPr sz="1300">
-                <a:solidFill>
-                  <a:srgbClr val="94A3B8"/>
+              <a:defRPr sz="1250">
+                <a:solidFill>
+                  <a:srgbClr val="334155"/>
                 </a:solidFill>
               </a:defRPr>
             </a:pPr>
@@ -3343,18 +3343,18 @@
         </p:nvSpPr>
         <p:spPr>
           <a:xfrm>
-            <a:off x="731520" y="4846320"/>
-            <a:ext cx="6217920" cy="1188720"/>
+            <a:off x="731520" y="4892040"/>
+            <a:ext cx="6217920" cy="1280160"/>
           </a:xfrm>
           <a:prstGeom prst="roundRect">
             <a:avLst/>
           </a:prstGeom>
           <a:solidFill>
-            <a:srgbClr val="131C31"/>
+            <a:srgbClr val="ECFDF5"/>
           </a:solidFill>
           <a:ln w="12700">
             <a:solidFill>
-              <a:srgbClr val="334155"/>
+              <a:srgbClr val="059669"/>
             </a:solidFill>
           </a:ln>
         </p:spPr>
@@ -3388,8 +3388,8 @@
         </p:nvSpPr>
         <p:spPr>
           <a:xfrm>
-            <a:off x="914400" y="4937760"/>
-            <a:ext cx="5852160" cy="1005840"/>
+            <a:off x="914400" y="4983480"/>
+            <a:ext cx="5852160" cy="1097280"/>
           </a:xfrm>
           <a:prstGeom prst="rect">
             <a:avLst/>
@@ -3405,7 +3405,7 @@
             <a:pPr>
               <a:defRPr sz="1000" b="1">
                 <a:solidFill>
-                  <a:srgbClr val="10B981"/>
+                  <a:srgbClr val="059669"/>
                 </a:solidFill>
               </a:defRPr>
             </a:pPr>
@@ -3417,7 +3417,7 @@
             <a:pPr>
               <a:defRPr sz="1300" b="1">
                 <a:solidFill>
-                  <a:srgbClr val="F8FAFC"/>
+                  <a:srgbClr val="0F172A"/>
                 </a:solidFill>
               </a:defRPr>
             </a:pPr>
@@ -3429,19 +3429,64 @@
             <a:pPr>
               <a:defRPr sz="1100">
                 <a:solidFill>
-                  <a:srgbClr val="06B6D4"/>
+                  <a:srgbClr val="0284C7"/>
                 </a:solidFill>
               </a:defRPr>
             </a:pPr>
             <a:r>
               <a:t>Live Control Plane: https://trust-state-eight.vercel.app/</a:t>
             </a:r>
+          </a:p>
+        </p:txBody>
+      </p:sp>
+      <p:sp>
+        <p:nvSpPr>
+          <p:cNvPr id="10" name="Rounded Rectangle 9"/>
+          <p:cNvSpPr/>
+          <p:nvPr/>
+        </p:nvSpPr>
+        <p:spPr>
+          <a:xfrm>
+            <a:off x="7086600" y="1051560"/>
+            <a:ext cx="4480560" cy="5029200"/>
+          </a:xfrm>
+          <a:prstGeom prst="roundRect">
+            <a:avLst/>
+          </a:prstGeom>
+          <a:solidFill>
+            <a:srgbClr val="FFFFFF"/>
+          </a:solidFill>
+          <a:ln w="12700">
+            <a:solidFill>
+              <a:srgbClr val="CBD5E1"/>
+            </a:solidFill>
+          </a:ln>
+        </p:spPr>
+        <p:style>
+          <a:lnRef idx="1">
+            <a:schemeClr val="accent1"/>
+          </a:lnRef>
+          <a:fillRef idx="3">
+            <a:schemeClr val="accent1"/>
+          </a:fillRef>
+          <a:effectRef idx="2">
+            <a:schemeClr val="accent1"/>
+          </a:effectRef>
+          <a:fontRef idx="minor">
+            <a:schemeClr val="lt1"/>
+          </a:fontRef>
+        </p:style>
+        <p:txBody>
+          <a:bodyPr rtlCol="0" anchor="ctr"/>
+          <a:lstStyle/>
+          <a:p>
+            <a:pPr algn="ctr"/>
           </a:p>
         </p:txBody>
       </p:sp>
       <p:pic>
         <p:nvPicPr>
-          <p:cNvPr id="10" name="Picture 9" descr="hero_landing.png"/>
+          <p:cNvPr id="11" name="Picture 10" descr="hero_landing.png"/>
           <p:cNvPicPr>
             <a:picLocks noChangeAspect="1"/>
           </p:cNvPicPr>
@@ -3496,7 +3541,7 @@
             <a:avLst/>
           </a:prstGeom>
           <a:solidFill>
-            <a:srgbClr val="0B1120"/>
+            <a:srgbClr val="F8FAFC"/>
           </a:solidFill>
           <a:ln>
             <a:noFill/>
@@ -3533,7 +3578,7 @@
         <p:spPr>
           <a:xfrm>
             <a:off x="731520" y="365760"/>
-            <a:ext cx="10698480" cy="365760"/>
+            <a:ext cx="10698480" cy="320040"/>
           </a:xfrm>
           <a:prstGeom prst="rect">
             <a:avLst/>
@@ -3549,7 +3594,7 @@
             <a:pPr>
               <a:defRPr sz="1000" b="1">
                 <a:solidFill>
-                  <a:srgbClr val="10B981"/>
+                  <a:srgbClr val="059669"/>
                 </a:solidFill>
                 <a:latin typeface="Calibri"/>
               </a:defRPr>
@@ -3569,7 +3614,7 @@
         <p:spPr>
           <a:xfrm>
             <a:off x="731520" y="640080"/>
-            <a:ext cx="10698480" cy="548640"/>
+            <a:ext cx="10698480" cy="502920"/>
           </a:xfrm>
           <a:prstGeom prst="rect">
             <a:avLst/>
@@ -3585,7 +3630,7 @@
             <a:pPr>
               <a:defRPr sz="2200" b="1">
                 <a:solidFill>
-                  <a:srgbClr val="F8FAFC"/>
+                  <a:srgbClr val="0F172A"/>
                 </a:solidFill>
                 <a:latin typeface="Calibri"/>
               </a:defRPr>
@@ -3604,8 +3649,8 @@
         </p:nvSpPr>
         <p:spPr>
           <a:xfrm>
-            <a:off x="731520" y="1143000"/>
-            <a:ext cx="10698480" cy="365760"/>
+            <a:off x="731520" y="1115568"/>
+            <a:ext cx="10698480" cy="320040"/>
           </a:xfrm>
           <a:prstGeom prst="rect">
             <a:avLst/>
@@ -3619,9 +3664,9 @@
           <a:lstStyle/>
           <a:p>
             <a:pPr>
-              <a:defRPr sz="1200">
-                <a:solidFill>
-                  <a:srgbClr val="94A3B8"/>
+              <a:defRPr sz="1150">
+                <a:solidFill>
+                  <a:srgbClr val="64748B"/>
                 </a:solidFill>
                 <a:latin typeface="Calibri"/>
               </a:defRPr>
@@ -3640,18 +3685,18 @@
         </p:nvSpPr>
         <p:spPr>
           <a:xfrm>
-            <a:off x="731520" y="1645920"/>
+            <a:off x="731520" y="1600200"/>
             <a:ext cx="5120640" cy="4389120"/>
           </a:xfrm>
           <a:prstGeom prst="roundRect">
             <a:avLst/>
           </a:prstGeom>
           <a:solidFill>
-            <a:srgbClr val="131C31"/>
+            <a:srgbClr val="FEF2F2"/>
           </a:solidFill>
           <a:ln w="12700">
             <a:solidFill>
-              <a:srgbClr val="334155"/>
+              <a:srgbClr val="DC2626"/>
             </a:solidFill>
           </a:ln>
         </p:spPr>
@@ -3685,7 +3730,7 @@
         </p:nvSpPr>
         <p:spPr>
           <a:xfrm>
-            <a:off x="1005840" y="1828800"/>
+            <a:off x="1005840" y="1783080"/>
             <a:ext cx="4572000" cy="4023360"/>
           </a:xfrm>
           <a:prstGeom prst="rect">
@@ -3700,9 +3745,9 @@
           <a:lstStyle/>
           <a:p>
             <a:pPr>
-              <a:defRPr sz="1600" b="1">
-                <a:solidFill>
-                  <a:srgbClr val="94A3B8"/>
+              <a:defRPr sz="1500" b="1">
+                <a:solidFill>
+                  <a:srgbClr val="DC2626"/>
                 </a:solidFill>
               </a:defRPr>
             </a:pPr>
@@ -3712,19 +3757,19 @@
           </a:p>
           <a:p>
             <a:pPr>
-              <a:defRPr b="1" sz="1200">
-                <a:solidFill>
-                  <a:srgbClr val="EF4444"/>
-                </a:solidFill>
-              </a:defRPr>
-            </a:pPr>
-            <a:r>
-              <a:t>- Static Boundary Question: </a:t>
+              <a:defRPr b="1" sz="1150">
+                <a:solidFill>
+                  <a:srgbClr val="0F172A"/>
+                </a:solidFill>
+              </a:defRPr>
+            </a:pPr>
+            <a:r>
+              <a:t>• Static Boundary Question: </a:t>
             </a:r>
             <a:r>
               <a:rPr b="0">
                 <a:solidFill>
-                  <a:srgbClr val="94A3B8"/>
+                  <a:srgbClr val="334155"/>
                 </a:solidFill>
               </a:rPr>
               <a:t>Answers 'Is this agent token allowed to call this API?'</a:t>
@@ -3732,62 +3777,62 @@
           </a:p>
           <a:p>
             <a:pPr>
-              <a:defRPr b="1" sz="1200">
-                <a:solidFill>
-                  <a:srgbClr val="EF4444"/>
-                </a:solidFill>
-              </a:defRPr>
-            </a:pPr>
-            <a:r>
-              <a:t>- Blind Spot: </a:t>
+              <a:defRPr b="1" sz="1150">
+                <a:solidFill>
+                  <a:srgbClr val="0F172A"/>
+                </a:solidFill>
+              </a:defRPr>
+            </a:pPr>
+            <a:r>
+              <a:t>• The Critical Blind Spot: </a:t>
             </a:r>
             <a:r>
               <a:rPr b="0">
                 <a:solidFill>
-                  <a:srgbClr val="94A3B8"/>
+                  <a:srgbClr val="334155"/>
                 </a:solidFill>
               </a:rPr>
-              <a:t>Cannot see if the agent's prompt was hijacked 2 seconds ago by indirect injection.</a:t>
-            </a:r>
-          </a:p>
-          <a:p>
-            <a:pPr>
-              <a:defRPr b="1" sz="1200">
-                <a:solidFill>
-                  <a:srgbClr val="EF4444"/>
-                </a:solidFill>
-              </a:defRPr>
-            </a:pPr>
-            <a:r>
-              <a:t>- Implicit Trust: </a:t>
+              <a:t>Cannot detect if the agent's prompt was rewritten 2 seconds ago by indirect injection.</a:t>
+            </a:r>
+          </a:p>
+          <a:p>
+            <a:pPr>
+              <a:defRPr b="1" sz="1150">
+                <a:solidFill>
+                  <a:srgbClr val="0F172A"/>
+                </a:solidFill>
+              </a:defRPr>
+            </a:pPr>
+            <a:r>
+              <a:t>• Implicit Trust Assumption: </a:t>
             </a:r>
             <a:r>
               <a:rPr b="0">
                 <a:solidFill>
-                  <a:srgbClr val="94A3B8"/>
+                  <a:srgbClr val="334155"/>
                 </a:solidFill>
               </a:rPr>
-              <a:t>Assumes that valid OAuth credentials equal untampered execution logic.</a:t>
-            </a:r>
-          </a:p>
-          <a:p>
-            <a:pPr>
-              <a:defRPr b="1" sz="1200">
-                <a:solidFill>
-                  <a:srgbClr val="EF4444"/>
-                </a:solidFill>
-              </a:defRPr>
-            </a:pPr>
-            <a:r>
-              <a:t>- Vulnerability: </a:t>
+              <a:t>Assumes valid OAuth credentials equal untampered execution logic.</a:t>
+            </a:r>
+          </a:p>
+          <a:p>
+            <a:pPr>
+              <a:defRPr b="1" sz="1150">
+                <a:solidFill>
+                  <a:srgbClr val="0F172A"/>
+                </a:solidFill>
+              </a:defRPr>
+            </a:pPr>
+            <a:r>
+              <a:t>• Exploitation Scenario: </a:t>
             </a:r>
             <a:r>
               <a:rPr b="0">
                 <a:solidFill>
-                  <a:srgbClr val="94A3B8"/>
+                  <a:srgbClr val="334155"/>
                 </a:solidFill>
               </a:rPr>
-              <a:t>Adversary injects malicious instructions inside invoice text -&gt; agent executes wire transfer using 100% valid enterprise API credentials.</a:t>
+              <a:t>Adversary injects malicious invoice instructions -&gt; agent executes wire transfer using 100% valid enterprise API tokens.</a:t>
             </a:r>
           </a:p>
         </p:txBody>
@@ -3800,18 +3845,18 @@
         </p:nvSpPr>
         <p:spPr>
           <a:xfrm>
-            <a:off x="6217920" y="1645920"/>
+            <a:off x="6217920" y="1600200"/>
             <a:ext cx="5212080" cy="4389120"/>
           </a:xfrm>
           <a:prstGeom prst="roundRect">
             <a:avLst/>
           </a:prstGeom>
           <a:solidFill>
-            <a:srgbClr val="131C31"/>
+            <a:srgbClr val="ECFDF5"/>
           </a:solidFill>
           <a:ln w="12700">
             <a:solidFill>
-              <a:srgbClr val="10B981"/>
+              <a:srgbClr val="059669"/>
             </a:solidFill>
           </a:ln>
         </p:spPr>
@@ -3845,7 +3890,7 @@
         </p:nvSpPr>
         <p:spPr>
           <a:xfrm>
-            <a:off x="6492240" y="1828800"/>
+            <a:off x="6492240" y="1783080"/>
             <a:ext cx="4663440" cy="4023360"/>
           </a:xfrm>
           <a:prstGeom prst="rect">
@@ -3860,9 +3905,9 @@
           <a:lstStyle/>
           <a:p>
             <a:pPr>
-              <a:defRPr sz="1600" b="1">
-                <a:solidFill>
-                  <a:srgbClr val="10B981"/>
+              <a:defRPr sz="1500" b="1">
+                <a:solidFill>
+                  <a:srgbClr val="059669"/>
                 </a:solidFill>
               </a:defRPr>
             </a:pPr>
@@ -3872,19 +3917,19 @@
           </a:p>
           <a:p>
             <a:pPr>
-              <a:defRPr b="1" sz="1200">
-                <a:solidFill>
-                  <a:srgbClr val="10B981"/>
-                </a:solidFill>
-              </a:defRPr>
-            </a:pPr>
-            <a:r>
-              <a:t>- Runtime Verification: </a:t>
+              <a:defRPr b="1" sz="1150">
+                <a:solidFill>
+                  <a:srgbClr val="0F172A"/>
+                </a:solidFill>
+              </a:defRPr>
+            </a:pPr>
+            <a:r>
+              <a:t>• Runtime State Verification: </a:t>
             </a:r>
             <a:r>
               <a:rPr b="0">
                 <a:solidFill>
-                  <a:srgbClr val="F8FAFC"/>
+                  <a:srgbClr val="334155"/>
                 </a:solidFill>
               </a:rPr>
               <a:t>Answers 'Is the agent still operating under the authorized state under which permission was granted?'</a:t>
@@ -3892,19 +3937,19 @@
           </a:p>
           <a:p>
             <a:pPr>
-              <a:defRPr b="1" sz="1200">
-                <a:solidFill>
-                  <a:srgbClr val="10B981"/>
-                </a:solidFill>
-              </a:defRPr>
-            </a:pPr>
-            <a:r>
-              <a:t>- Cryptographic Grounding: </a:t>
+              <a:defRPr b="1" sz="1150">
+                <a:solidFill>
+                  <a:srgbClr val="0F172A"/>
+                </a:solidFill>
+              </a:defRPr>
+            </a:pPr>
+            <a:r>
+              <a:t>• Cryptographic Commitment: </a:t>
             </a:r>
             <a:r>
               <a:rPr b="0">
                 <a:solidFill>
-                  <a:srgbClr val="F8FAFC"/>
+                  <a:srgbClr val="334155"/>
                 </a:solidFill>
               </a:rPr>
               <a:t>Protected Execution State (PES) canonicalized &amp; committed via SHA-256 hash.</a:t>
@@ -3912,39 +3957,39 @@
           </a:p>
           <a:p>
             <a:pPr>
-              <a:defRPr b="1" sz="1200">
-                <a:solidFill>
-                  <a:srgbClr val="10B981"/>
-                </a:solidFill>
-              </a:defRPr>
-            </a:pPr>
-            <a:r>
-              <a:t>- Inline Circuit Breaker: </a:t>
+              <a:defRPr b="1" sz="1150">
+                <a:solidFill>
+                  <a:srgbClr val="0F172A"/>
+                </a:solidFill>
+              </a:defRPr>
+            </a:pPr>
+            <a:r>
+              <a:t>• Sub-2ms Circuit Breaker: </a:t>
             </a:r>
             <a:r>
               <a:rPr b="0">
                 <a:solidFill>
-                  <a:srgbClr val="F8FAFC"/>
+                  <a:srgbClr val="334155"/>
                 </a:solidFill>
               </a:rPr>
-              <a:t>If observed state != trusted state, privileged execution is frozen in &lt;2ms before high-impact tool execution.</a:t>
-            </a:r>
-          </a:p>
-          <a:p>
-            <a:pPr>
-              <a:defRPr b="1" sz="1200">
-                <a:solidFill>
-                  <a:srgbClr val="10B981"/>
-                </a:solidFill>
-              </a:defRPr>
-            </a:pPr>
-            <a:r>
-              <a:t>- Result: </a:t>
+              <a:t>If observed state != trusted state, privileged execution is frozen before high-impact tool execution.</a:t>
+            </a:r>
+          </a:p>
+          <a:p>
+            <a:pPr>
+              <a:defRPr b="1" sz="1150">
+                <a:solidFill>
+                  <a:srgbClr val="0F172A"/>
+                </a:solidFill>
+              </a:defRPr>
+            </a:pPr>
+            <a:r>
+              <a:t>• Zero Unauthorized Escapes: </a:t>
             </a:r>
             <a:r>
               <a:rPr b="0">
                 <a:solidFill>
-                  <a:srgbClr val="F8FAFC"/>
+                  <a:srgbClr val="334155"/>
                 </a:solidFill>
               </a:rPr>
               <a:t>Zero unauthorized state mutations gain privileged execution, even when the LLM is completely tricked.</a:t>
@@ -3960,18 +4005,18 @@
         </p:nvSpPr>
         <p:spPr>
           <a:xfrm>
-            <a:off x="731520" y="6217920"/>
-            <a:ext cx="10698480" cy="411480"/>
+            <a:off x="731520" y="6126480"/>
+            <a:ext cx="10698480" cy="438912"/>
           </a:xfrm>
           <a:prstGeom prst="roundRect">
             <a:avLst/>
           </a:prstGeom>
           <a:solidFill>
-            <a:srgbClr val="131C31"/>
+            <a:srgbClr val="FFFFFF"/>
           </a:solidFill>
           <a:ln w="12700">
             <a:solidFill>
-              <a:srgbClr val="334155"/>
+              <a:srgbClr val="CBD5E1"/>
             </a:solidFill>
           </a:ln>
         </p:spPr>
@@ -4005,7 +4050,7 @@
         </p:nvSpPr>
         <p:spPr>
           <a:xfrm>
-            <a:off x="731520" y="6172200"/>
+            <a:off x="731520" y="6108192"/>
             <a:ext cx="10698480" cy="365760"/>
           </a:xfrm>
           <a:prstGeom prst="rect">
@@ -4022,7 +4067,7 @@
             <a:pPr algn="ctr">
               <a:defRPr sz="1100" b="1">
                 <a:solidFill>
-                  <a:srgbClr val="06B6D4"/>
+                  <a:srgbClr val="0284C7"/>
                 </a:solidFill>
               </a:defRPr>
             </a:pPr>
@@ -4065,7 +4110,7 @@
             <a:avLst/>
           </a:prstGeom>
           <a:solidFill>
-            <a:srgbClr val="0B1120"/>
+            <a:srgbClr val="F8FAFC"/>
           </a:solidFill>
           <a:ln>
             <a:noFill/>
@@ -4102,7 +4147,7 @@
         <p:spPr>
           <a:xfrm>
             <a:off x="731520" y="365760"/>
-            <a:ext cx="10698480" cy="365760"/>
+            <a:ext cx="10698480" cy="320040"/>
           </a:xfrm>
           <a:prstGeom prst="rect">
             <a:avLst/>
@@ -4118,7 +4163,7 @@
             <a:pPr>
               <a:defRPr sz="1000" b="1">
                 <a:solidFill>
-                  <a:srgbClr val="10B981"/>
+                  <a:srgbClr val="059669"/>
                 </a:solidFill>
                 <a:latin typeface="Calibri"/>
               </a:defRPr>
@@ -4138,7 +4183,7 @@
         <p:spPr>
           <a:xfrm>
             <a:off x="731520" y="640080"/>
-            <a:ext cx="10698480" cy="548640"/>
+            <a:ext cx="10698480" cy="502920"/>
           </a:xfrm>
           <a:prstGeom prst="rect">
             <a:avLst/>
@@ -4154,7 +4199,7 @@
             <a:pPr>
               <a:defRPr sz="2200" b="1">
                 <a:solidFill>
-                  <a:srgbClr val="F8FAFC"/>
+                  <a:srgbClr val="0F172A"/>
                 </a:solidFill>
                 <a:latin typeface="Calibri"/>
               </a:defRPr>
@@ -4173,8 +4218,8 @@
         </p:nvSpPr>
         <p:spPr>
           <a:xfrm>
-            <a:off x="731520" y="1143000"/>
-            <a:ext cx="10698480" cy="365760"/>
+            <a:off x="731520" y="1115568"/>
+            <a:ext cx="10698480" cy="320040"/>
           </a:xfrm>
           <a:prstGeom prst="rect">
             <a:avLst/>
@@ -4188,9 +4233,9 @@
           <a:lstStyle/>
           <a:p>
             <a:pPr>
-              <a:defRPr sz="1200">
-                <a:solidFill>
-                  <a:srgbClr val="94A3B8"/>
+              <a:defRPr sz="1150">
+                <a:solidFill>
+                  <a:srgbClr val="64748B"/>
                 </a:solidFill>
                 <a:latin typeface="Calibri"/>
               </a:defRPr>
@@ -4209,18 +4254,18 @@
         </p:nvSpPr>
         <p:spPr>
           <a:xfrm>
-            <a:off x="731520" y="1645920"/>
-            <a:ext cx="3383280" cy="4663440"/>
+            <a:off x="731520" y="1600200"/>
+            <a:ext cx="3383280" cy="4754880"/>
           </a:xfrm>
           <a:prstGeom prst="roundRect">
             <a:avLst/>
           </a:prstGeom>
           <a:solidFill>
-            <a:srgbClr val="131C31"/>
+            <a:srgbClr val="FFFFFF"/>
           </a:solidFill>
           <a:ln w="12700">
             <a:solidFill>
-              <a:srgbClr val="10B981"/>
+              <a:srgbClr val="059669"/>
             </a:solidFill>
           </a:ln>
         </p:spPr>
@@ -4254,8 +4299,8 @@
         </p:nvSpPr>
         <p:spPr>
           <a:xfrm>
-            <a:off x="914400" y="1828800"/>
-            <a:ext cx="3017520" cy="4297680"/>
+            <a:off x="914400" y="1783080"/>
+            <a:ext cx="3017520" cy="4389120"/>
           </a:xfrm>
           <a:prstGeom prst="rect">
             <a:avLst/>
@@ -4269,33 +4314,33 @@
           <a:lstStyle/>
           <a:p>
             <a:pPr>
-              <a:defRPr sz="1400" b="1">
-                <a:solidFill>
-                  <a:srgbClr val="10B981"/>
-                </a:solidFill>
-              </a:defRPr>
-            </a:pPr>
-            <a:r>
-              <a:t>Tier 1: Protected Execution State (PES)</a:t>
-            </a:r>
-          </a:p>
-          <a:p>
-            <a:pPr>
-              <a:defRPr sz="1000">
-                <a:solidFill>
-                  <a:srgbClr val="94A3B8"/>
-                </a:solidFill>
-              </a:defRPr>
-            </a:pPr>
-            <a:r>
-              <a:t>Cryptographically Committed via SHA-256</a:t>
+              <a:defRPr sz="1350" b="1">
+                <a:solidFill>
+                  <a:srgbClr val="059669"/>
+                </a:solidFill>
+              </a:defRPr>
+            </a:pPr>
+            <a:r>
+              <a:t>Tier 1: Protected Execution State</a:t>
+            </a:r>
+          </a:p>
+          <a:p>
+            <a:pPr>
+              <a:defRPr sz="1000" b="1">
+                <a:solidFill>
+                  <a:srgbClr val="64748B"/>
+                </a:solidFill>
+              </a:defRPr>
+            </a:pPr>
+            <a:r>
+              <a:t>SHA-256 Cryptographic Commitment</a:t>
             </a:r>
           </a:p>
           <a:p>
             <a:pPr>
               <a:defRPr sz="1100">
                 <a:solidFill>
-                  <a:srgbClr val="F8FAFC"/>
+                  <a:srgbClr val="334155"/>
                 </a:solidFill>
               </a:defRPr>
             </a:pPr>
@@ -4307,7 +4352,7 @@
             <a:pPr>
               <a:defRPr sz="1100">
                 <a:solidFill>
-                  <a:srgbClr val="F8FAFC"/>
+                  <a:srgbClr val="334155"/>
                 </a:solidFill>
               </a:defRPr>
             </a:pPr>
@@ -4319,7 +4364,7 @@
             <a:pPr>
               <a:defRPr sz="1100">
                 <a:solidFill>
-                  <a:srgbClr val="F8FAFC"/>
+                  <a:srgbClr val="334155"/>
                 </a:solidFill>
               </a:defRPr>
             </a:pPr>
@@ -4331,7 +4376,7 @@
             <a:pPr>
               <a:defRPr sz="1100">
                 <a:solidFill>
-                  <a:srgbClr val="F8FAFC"/>
+                  <a:srgbClr val="334155"/>
                 </a:solidFill>
               </a:defRPr>
             </a:pPr>
@@ -4343,7 +4388,7 @@
             <a:pPr>
               <a:defRPr sz="1100" b="1">
                 <a:solidFill>
-                  <a:srgbClr val="10B981"/>
+                  <a:srgbClr val="059669"/>
                 </a:solidFill>
               </a:defRPr>
             </a:pPr>
@@ -4361,18 +4406,18 @@
         </p:nvSpPr>
         <p:spPr>
           <a:xfrm>
-            <a:off x="4389120" y="1645920"/>
-            <a:ext cx="3383280" cy="4663440"/>
+            <a:off x="4389120" y="1600200"/>
+            <a:ext cx="3383280" cy="4754880"/>
           </a:xfrm>
           <a:prstGeom prst="roundRect">
             <a:avLst/>
           </a:prstGeom>
           <a:solidFill>
-            <a:srgbClr val="131C31"/>
+            <a:srgbClr val="FFFFFF"/>
           </a:solidFill>
           <a:ln w="12700">
             <a:solidFill>
-              <a:srgbClr val="6366F1"/>
+              <a:srgbClr val="4F46E5"/>
             </a:solidFill>
           </a:ln>
         </p:spPr>
@@ -4406,8 +4451,8 @@
         </p:nvSpPr>
         <p:spPr>
           <a:xfrm>
-            <a:off x="4572000" y="1828800"/>
-            <a:ext cx="3017520" cy="4297680"/>
+            <a:off x="4572000" y="1783080"/>
+            <a:ext cx="3017520" cy="4389120"/>
           </a:xfrm>
           <a:prstGeom prst="rect">
             <a:avLst/>
@@ -4421,9 +4466,9 @@
           <a:lstStyle/>
           <a:p>
             <a:pPr>
-              <a:defRPr sz="1400" b="1">
-                <a:solidFill>
-                  <a:srgbClr val="6366F1"/>
+              <a:defRPr sz="1350" b="1">
+                <a:solidFill>
+                  <a:srgbClr val="4F46E5"/>
                 </a:solidFill>
               </a:defRPr>
             </a:pPr>
@@ -4433,9 +4478,9 @@
           </a:p>
           <a:p>
             <a:pPr>
-              <a:defRPr sz="1000">
-                <a:solidFill>
-                  <a:srgbClr val="94A3B8"/>
+              <a:defRPr sz="1000" b="1">
+                <a:solidFill>
+                  <a:srgbClr val="64748B"/>
                 </a:solidFill>
               </a:defRPr>
             </a:pPr>
@@ -4447,7 +4492,7 @@
             <a:pPr>
               <a:defRPr sz="1100">
                 <a:solidFill>
-                  <a:srgbClr val="F8FAFC"/>
+                  <a:srgbClr val="334155"/>
                 </a:solidFill>
               </a:defRPr>
             </a:pPr>
@@ -4459,7 +4504,7 @@
             <a:pPr>
               <a:defRPr sz="1100">
                 <a:solidFill>
-                  <a:srgbClr val="F8FAFC"/>
+                  <a:srgbClr val="334155"/>
                 </a:solidFill>
               </a:defRPr>
             </a:pPr>
@@ -4471,7 +4516,7 @@
             <a:pPr>
               <a:defRPr sz="1100">
                 <a:solidFill>
-                  <a:srgbClr val="F8FAFC"/>
+                  <a:srgbClr val="334155"/>
                 </a:solidFill>
               </a:defRPr>
             </a:pPr>
@@ -4483,7 +4528,7 @@
             <a:pPr>
               <a:defRPr sz="1100">
                 <a:solidFill>
-                  <a:srgbClr val="F8FAFC"/>
+                  <a:srgbClr val="334155"/>
                 </a:solidFill>
               </a:defRPr>
             </a:pPr>
@@ -4495,7 +4540,7 @@
             <a:pPr>
               <a:defRPr sz="1100" b="1">
                 <a:solidFill>
-                  <a:srgbClr val="6366F1"/>
+                  <a:srgbClr val="4F46E5"/>
                 </a:solidFill>
               </a:defRPr>
             </a:pPr>
@@ -4513,18 +4558,18 @@
         </p:nvSpPr>
         <p:spPr>
           <a:xfrm>
-            <a:off x="8046720" y="1645920"/>
-            <a:ext cx="3383280" cy="4663440"/>
+            <a:off x="8046720" y="1600200"/>
+            <a:ext cx="3383280" cy="4754880"/>
           </a:xfrm>
           <a:prstGeom prst="roundRect">
             <a:avLst/>
           </a:prstGeom>
           <a:solidFill>
-            <a:srgbClr val="131C31"/>
+            <a:srgbClr val="FFFFFF"/>
           </a:solidFill>
           <a:ln w="12700">
             <a:solidFill>
-              <a:srgbClr val="06B6D4"/>
+              <a:srgbClr val="0284C7"/>
             </a:solidFill>
           </a:ln>
         </p:spPr>
@@ -4558,8 +4603,8 @@
         </p:nvSpPr>
         <p:spPr>
           <a:xfrm>
-            <a:off x="8229600" y="1828800"/>
-            <a:ext cx="3017520" cy="4297680"/>
+            <a:off x="8229600" y="1783080"/>
+            <a:ext cx="3017520" cy="4389120"/>
           </a:xfrm>
           <a:prstGeom prst="rect">
             <a:avLst/>
@@ -4573,9 +4618,9 @@
           <a:lstStyle/>
           <a:p>
             <a:pPr>
-              <a:defRPr sz="1400" b="1">
-                <a:solidFill>
-                  <a:srgbClr val="06B6D4"/>
+              <a:defRPr sz="1350" b="1">
+                <a:solidFill>
+                  <a:srgbClr val="0284C7"/>
                 </a:solidFill>
               </a:defRPr>
             </a:pPr>
@@ -4585,9 +4630,9 @@
           </a:p>
           <a:p>
             <a:pPr>
-              <a:defRPr sz="1000">
-                <a:solidFill>
-                  <a:srgbClr val="94A3B8"/>
+              <a:defRPr sz="1000" b="1">
+                <a:solidFill>
+                  <a:srgbClr val="64748B"/>
                 </a:solidFill>
               </a:defRPr>
             </a:pPr>
@@ -4599,7 +4644,7 @@
             <a:pPr>
               <a:defRPr sz="1100">
                 <a:solidFill>
-                  <a:srgbClr val="F8FAFC"/>
+                  <a:srgbClr val="334155"/>
                 </a:solidFill>
               </a:defRPr>
             </a:pPr>
@@ -4611,7 +4656,7 @@
             <a:pPr>
               <a:defRPr sz="1100">
                 <a:solidFill>
-                  <a:srgbClr val="F8FAFC"/>
+                  <a:srgbClr val="334155"/>
                 </a:solidFill>
               </a:defRPr>
             </a:pPr>
@@ -4623,7 +4668,7 @@
             <a:pPr>
               <a:defRPr sz="1100">
                 <a:solidFill>
-                  <a:srgbClr val="F8FAFC"/>
+                  <a:srgbClr val="334155"/>
                 </a:solidFill>
               </a:defRPr>
             </a:pPr>
@@ -4635,7 +4680,7 @@
             <a:pPr>
               <a:defRPr sz="1100">
                 <a:solidFill>
-                  <a:srgbClr val="F8FAFC"/>
+                  <a:srgbClr val="334155"/>
                 </a:solidFill>
               </a:defRPr>
             </a:pPr>
@@ -4647,7 +4692,7 @@
             <a:pPr>
               <a:defRPr sz="1100" b="1">
                 <a:solidFill>
-                  <a:srgbClr val="06B6D4"/>
+                  <a:srgbClr val="0284C7"/>
                 </a:solidFill>
               </a:defRPr>
             </a:pPr>
@@ -4690,7 +4735,7 @@
             <a:avLst/>
           </a:prstGeom>
           <a:solidFill>
-            <a:srgbClr val="0B1120"/>
+            <a:srgbClr val="F8FAFC"/>
           </a:solidFill>
           <a:ln>
             <a:noFill/>
@@ -4727,7 +4772,7 @@
         <p:spPr>
           <a:xfrm>
             <a:off x="731520" y="365760"/>
-            <a:ext cx="10698480" cy="365760"/>
+            <a:ext cx="10698480" cy="320040"/>
           </a:xfrm>
           <a:prstGeom prst="rect">
             <a:avLst/>
@@ -4743,7 +4788,7 @@
             <a:pPr>
               <a:defRPr sz="1000" b="1">
                 <a:solidFill>
-                  <a:srgbClr val="10B981"/>
+                  <a:srgbClr val="059669"/>
                 </a:solidFill>
                 <a:latin typeface="Calibri"/>
               </a:defRPr>
@@ -4763,7 +4808,7 @@
         <p:spPr>
           <a:xfrm>
             <a:off x="731520" y="640080"/>
-            <a:ext cx="10698480" cy="548640"/>
+            <a:ext cx="10698480" cy="502920"/>
           </a:xfrm>
           <a:prstGeom prst="rect">
             <a:avLst/>
@@ -4779,7 +4824,7 @@
             <a:pPr>
               <a:defRPr sz="2200" b="1">
                 <a:solidFill>
-                  <a:srgbClr val="F8FAFC"/>
+                  <a:srgbClr val="0F172A"/>
                 </a:solidFill>
                 <a:latin typeface="Calibri"/>
               </a:defRPr>
@@ -4798,8 +4843,8 @@
         </p:nvSpPr>
         <p:spPr>
           <a:xfrm>
-            <a:off x="731520" y="1143000"/>
-            <a:ext cx="10698480" cy="365760"/>
+            <a:off x="731520" y="1115568"/>
+            <a:ext cx="10698480" cy="320040"/>
           </a:xfrm>
           <a:prstGeom prst="rect">
             <a:avLst/>
@@ -4813,9 +4858,9 @@
           <a:lstStyle/>
           <a:p>
             <a:pPr>
-              <a:defRPr sz="1200">
-                <a:solidFill>
-                  <a:srgbClr val="94A3B8"/>
+              <a:defRPr sz="1150">
+                <a:solidFill>
+                  <a:srgbClr val="64748B"/>
                 </a:solidFill>
                 <a:latin typeface="Calibri"/>
               </a:defRPr>
@@ -4834,18 +4879,18 @@
         </p:nvSpPr>
         <p:spPr>
           <a:xfrm>
-            <a:off x="731520" y="1645920"/>
-            <a:ext cx="4389120" cy="4663440"/>
+            <a:off x="731520" y="1600200"/>
+            <a:ext cx="4389120" cy="4754880"/>
           </a:xfrm>
           <a:prstGeom prst="roundRect">
             <a:avLst/>
           </a:prstGeom>
           <a:solidFill>
-            <a:srgbClr val="131C31"/>
+            <a:srgbClr val="FFFFFF"/>
           </a:solidFill>
           <a:ln w="12700">
             <a:solidFill>
-              <a:srgbClr val="334155"/>
+              <a:srgbClr val="CBD5E1"/>
             </a:solidFill>
           </a:ln>
         </p:spPr>
@@ -4879,8 +4924,8 @@
         </p:nvSpPr>
         <p:spPr>
           <a:xfrm>
-            <a:off x="914400" y="1828800"/>
-            <a:ext cx="4023360" cy="4297680"/>
+            <a:off x="914400" y="1783080"/>
+            <a:ext cx="4023360" cy="4389120"/>
           </a:xfrm>
           <a:prstGeom prst="rect">
             <a:avLst/>
@@ -4894,9 +4939,9 @@
           <a:lstStyle/>
           <a:p>
             <a:pPr>
-              <a:defRPr sz="1600" b="1">
-                <a:solidFill>
-                  <a:srgbClr val="F8FAFC"/>
+              <a:defRPr sz="1500" b="1">
+                <a:solidFill>
+                  <a:srgbClr val="0F172A"/>
                 </a:solidFill>
               </a:defRPr>
             </a:pPr>
@@ -4906,9 +4951,9 @@
           </a:p>
           <a:p>
             <a:pPr>
-              <a:defRPr b="1" sz="1200">
-                <a:solidFill>
-                  <a:srgbClr val="EF4444"/>
+              <a:defRPr b="1" sz="1150">
+                <a:solidFill>
+                  <a:srgbClr val="DC2626"/>
                 </a:solidFill>
               </a:defRPr>
             </a:pPr>
@@ -4920,7 +4965,7 @@
             <a:pPr>
               <a:defRPr sz="1050">
                 <a:solidFill>
-                  <a:srgbClr val="94A3B8"/>
+                  <a:srgbClr val="334155"/>
                 </a:solidFill>
               </a:defRPr>
             </a:pPr>
@@ -4930,9 +4975,9 @@
           </a:p>
           <a:p>
             <a:pPr>
-              <a:defRPr b="1" sz="1200">
-                <a:solidFill>
-                  <a:srgbClr val="06B6D4"/>
+              <a:defRPr b="1" sz="1150">
+                <a:solidFill>
+                  <a:srgbClr val="0284C7"/>
                 </a:solidFill>
               </a:defRPr>
             </a:pPr>
@@ -4944,19 +4989,19 @@
             <a:pPr>
               <a:defRPr sz="1050">
                 <a:solidFill>
-                  <a:srgbClr val="94A3B8"/>
-                </a:solidFill>
-              </a:defRPr>
-            </a:pPr>
-            <a:r>
-              <a:t>RFC 8785 Canonicalizer, SHA-256 Ledger, and sub-15ms local cache. Verifies cryptographic commitments and mints short-lived signed state leases.</a:t>
-            </a:r>
-          </a:p>
-          <a:p>
-            <a:pPr>
-              <a:defRPr b="1" sz="1200">
-                <a:solidFill>
-                  <a:srgbClr val="10B981"/>
+                  <a:srgbClr val="334155"/>
+                </a:solidFill>
+              </a:defRPr>
+            </a:pPr>
+            <a:r>
+              <a:t>RFC 8785 Canonicalizer, SHA-256 State Ledger, and sub-15ms local cache. Verifies cryptographic commitments and mints short-lived signed state leases.</a:t>
+            </a:r>
+          </a:p>
+          <a:p>
+            <a:pPr>
+              <a:defRPr b="1" sz="1150">
+                <a:solidFill>
+                  <a:srgbClr val="059669"/>
                 </a:solidFill>
               </a:defRPr>
             </a:pPr>
@@ -4968,19 +5013,64 @@
             <a:pPr>
               <a:defRPr sz="1050">
                 <a:solidFill>
-                  <a:srgbClr val="94A3B8"/>
+                  <a:srgbClr val="334155"/>
                 </a:solidFill>
               </a:defRPr>
             </a:pPr>
             <a:r>
               <a:t>Databases, payment gateways, wire transfers, production infrastructure. Enforces that requests must provide a valid TrustState lease token.</a:t>
             </a:r>
+          </a:p>
+        </p:txBody>
+      </p:sp>
+      <p:sp>
+        <p:nvSpPr>
+          <p:cNvPr id="8" name="Rounded Rectangle 7"/>
+          <p:cNvSpPr/>
+          <p:nvPr/>
+        </p:nvSpPr>
+        <p:spPr>
+          <a:xfrm>
+            <a:off x="5349240" y="1554480"/>
+            <a:ext cx="6126480" cy="4846320"/>
+          </a:xfrm>
+          <a:prstGeom prst="roundRect">
+            <a:avLst/>
+          </a:prstGeom>
+          <a:solidFill>
+            <a:srgbClr val="FFFFFF"/>
+          </a:solidFill>
+          <a:ln w="12700">
+            <a:solidFill>
+              <a:srgbClr val="CBD5E1"/>
+            </a:solidFill>
+          </a:ln>
+        </p:spPr>
+        <p:style>
+          <a:lnRef idx="1">
+            <a:schemeClr val="accent1"/>
+          </a:lnRef>
+          <a:fillRef idx="3">
+            <a:schemeClr val="accent1"/>
+          </a:fillRef>
+          <a:effectRef idx="2">
+            <a:schemeClr val="accent1"/>
+          </a:effectRef>
+          <a:fontRef idx="minor">
+            <a:schemeClr val="lt1"/>
+          </a:fontRef>
+        </p:style>
+        <p:txBody>
+          <a:bodyPr rtlCol="0" anchor="ctr"/>
+          <a:lstStyle/>
+          <a:p>
+            <a:pPr algn="ctr"/>
           </a:p>
         </p:txBody>
       </p:sp>
       <p:pic>
         <p:nvPicPr>
-          <p:cNvPr id="8" name="Picture 7" descr="architecture_diagram.png"/>
+          <p:cNvPr id="9" name="Picture 8" descr="architecture_diagram.png"/>
           <p:cNvPicPr>
             <a:picLocks noChangeAspect="1"/>
           </p:cNvPicPr>
@@ -4994,8 +5084,8 @@
         </p:blipFill>
         <p:spPr>
           <a:xfrm>
-            <a:off x="5394960" y="1645920"/>
-            <a:ext cx="6035040" cy="4663440"/>
+            <a:off x="5394960" y="1600200"/>
+            <a:ext cx="6035040" cy="4754880"/>
           </a:xfrm>
           <a:prstGeom prst="rect">
             <a:avLst/>
@@ -5035,7 +5125,7 @@
             <a:avLst/>
           </a:prstGeom>
           <a:solidFill>
-            <a:srgbClr val="0B1120"/>
+            <a:srgbClr val="F8FAFC"/>
           </a:solidFill>
           <a:ln>
             <a:noFill/>
@@ -5072,7 +5162,7 @@
         <p:spPr>
           <a:xfrm>
             <a:off x="731520" y="365760"/>
-            <a:ext cx="10698480" cy="365760"/>
+            <a:ext cx="10698480" cy="320040"/>
           </a:xfrm>
           <a:prstGeom prst="rect">
             <a:avLst/>
@@ -5088,7 +5178,7 @@
             <a:pPr>
               <a:defRPr sz="1000" b="1">
                 <a:solidFill>
-                  <a:srgbClr val="10B981"/>
+                  <a:srgbClr val="059669"/>
                 </a:solidFill>
                 <a:latin typeface="Calibri"/>
               </a:defRPr>
@@ -5108,7 +5198,7 @@
         <p:spPr>
           <a:xfrm>
             <a:off x="731520" y="640080"/>
-            <a:ext cx="10698480" cy="548640"/>
+            <a:ext cx="10698480" cy="502920"/>
           </a:xfrm>
           <a:prstGeom prst="rect">
             <a:avLst/>
@@ -5124,7 +5214,7 @@
             <a:pPr>
               <a:defRPr sz="2200" b="1">
                 <a:solidFill>
-                  <a:srgbClr val="F8FAFC"/>
+                  <a:srgbClr val="0F172A"/>
                 </a:solidFill>
                 <a:latin typeface="Calibri"/>
               </a:defRPr>
@@ -5143,8 +5233,8 @@
         </p:nvSpPr>
         <p:spPr>
           <a:xfrm>
-            <a:off x="731520" y="1143000"/>
-            <a:ext cx="10698480" cy="365760"/>
+            <a:off x="731520" y="1115568"/>
+            <a:ext cx="10698480" cy="320040"/>
           </a:xfrm>
           <a:prstGeom prst="rect">
             <a:avLst/>
@@ -5158,9 +5248,9 @@
           <a:lstStyle/>
           <a:p>
             <a:pPr>
-              <a:defRPr sz="1200">
-                <a:solidFill>
-                  <a:srgbClr val="94A3B8"/>
+              <a:defRPr sz="1150">
+                <a:solidFill>
+                  <a:srgbClr val="64748B"/>
                 </a:solidFill>
                 <a:latin typeface="Calibri"/>
               </a:defRPr>
@@ -5179,18 +5269,18 @@
         </p:nvSpPr>
         <p:spPr>
           <a:xfrm>
-            <a:off x="731520" y="1645920"/>
-            <a:ext cx="4389120" cy="1051560"/>
+            <a:off x="731520" y="1600200"/>
+            <a:ext cx="4389120" cy="1097280"/>
           </a:xfrm>
           <a:prstGeom prst="roundRect">
             <a:avLst/>
           </a:prstGeom>
           <a:solidFill>
-            <a:srgbClr val="131C31"/>
+            <a:srgbClr val="FFFFFF"/>
           </a:solidFill>
           <a:ln w="12700">
             <a:solidFill>
-              <a:srgbClr val="334155"/>
+              <a:srgbClr val="CBD5E1"/>
             </a:solidFill>
           </a:ln>
         </p:spPr>
@@ -5224,8 +5314,8 @@
         </p:nvSpPr>
         <p:spPr>
           <a:xfrm>
-            <a:off x="914400" y="1737360"/>
-            <a:ext cx="4023360" cy="868680"/>
+            <a:off x="914400" y="1673352"/>
+            <a:ext cx="4023360" cy="914400"/>
           </a:xfrm>
           <a:prstGeom prst="rect">
             <a:avLst/>
@@ -5241,7 +5331,7 @@
             <a:pPr>
               <a:defRPr sz="1300" b="1">
                 <a:solidFill>
-                  <a:srgbClr val="10B981"/>
+                  <a:srgbClr val="059669"/>
                 </a:solidFill>
               </a:defRPr>
             </a:pPr>
@@ -5251,9 +5341,9 @@
           </a:p>
           <a:p>
             <a:pPr>
-              <a:defRPr sz="1000">
-                <a:solidFill>
-                  <a:srgbClr val="94A3B8"/>
+              <a:defRPr sz="1050">
+                <a:solidFill>
+                  <a:srgbClr val="334155"/>
                 </a:solidFill>
               </a:defRPr>
             </a:pPr>
@@ -5272,17 +5362,17 @@
         <p:spPr>
           <a:xfrm>
             <a:off x="731520" y="2788920"/>
-            <a:ext cx="4389120" cy="1051560"/>
+            <a:ext cx="4389120" cy="1097280"/>
           </a:xfrm>
           <a:prstGeom prst="roundRect">
             <a:avLst/>
           </a:prstGeom>
           <a:solidFill>
-            <a:srgbClr val="131C31"/>
+            <a:srgbClr val="FFFFFF"/>
           </a:solidFill>
           <a:ln w="12700">
             <a:solidFill>
-              <a:srgbClr val="334155"/>
+              <a:srgbClr val="CBD5E1"/>
             </a:solidFill>
           </a:ln>
         </p:spPr>
@@ -5316,8 +5406,8 @@
         </p:nvSpPr>
         <p:spPr>
           <a:xfrm>
-            <a:off x="914400" y="2880360"/>
-            <a:ext cx="4023360" cy="868680"/>
+            <a:off x="914400" y="2862072"/>
+            <a:ext cx="4023360" cy="914400"/>
           </a:xfrm>
           <a:prstGeom prst="rect">
             <a:avLst/>
@@ -5333,7 +5423,7 @@
             <a:pPr>
               <a:defRPr sz="1300" b="1">
                 <a:solidFill>
-                  <a:srgbClr val="06B6D4"/>
+                  <a:srgbClr val="0284C7"/>
                 </a:solidFill>
               </a:defRPr>
             </a:pPr>
@@ -5343,9 +5433,9 @@
           </a:p>
           <a:p>
             <a:pPr>
-              <a:defRPr sz="1000">
-                <a:solidFill>
-                  <a:srgbClr val="94A3B8"/>
+              <a:defRPr sz="1050">
+                <a:solidFill>
+                  <a:srgbClr val="334155"/>
                 </a:solidFill>
               </a:defRPr>
             </a:pPr>
@@ -5363,18 +5453,18 @@
         </p:nvSpPr>
         <p:spPr>
           <a:xfrm>
-            <a:off x="731520" y="3931920"/>
-            <a:ext cx="4389120" cy="1051560"/>
+            <a:off x="731520" y="3977639"/>
+            <a:ext cx="4389120" cy="1097280"/>
           </a:xfrm>
           <a:prstGeom prst="roundRect">
             <a:avLst/>
           </a:prstGeom>
           <a:solidFill>
-            <a:srgbClr val="131C31"/>
+            <a:srgbClr val="FFFFFF"/>
           </a:solidFill>
           <a:ln w="12700">
             <a:solidFill>
-              <a:srgbClr val="334155"/>
+              <a:srgbClr val="CBD5E1"/>
             </a:solidFill>
           </a:ln>
         </p:spPr>
@@ -5408,8 +5498,8 @@
         </p:nvSpPr>
         <p:spPr>
           <a:xfrm>
-            <a:off x="914400" y="4023360"/>
-            <a:ext cx="4023360" cy="868680"/>
+            <a:off x="914400" y="4050791"/>
+            <a:ext cx="4023360" cy="914400"/>
           </a:xfrm>
           <a:prstGeom prst="rect">
             <a:avLst/>
@@ -5425,7 +5515,7 @@
             <a:pPr>
               <a:defRPr sz="1300" b="1">
                 <a:solidFill>
-                  <a:srgbClr val="6366F1"/>
+                  <a:srgbClr val="4F46E5"/>
                 </a:solidFill>
               </a:defRPr>
             </a:pPr>
@@ -5435,9 +5525,9 @@
           </a:p>
           <a:p>
             <a:pPr>
-              <a:defRPr sz="1000">
-                <a:solidFill>
-                  <a:srgbClr val="94A3B8"/>
+              <a:defRPr sz="1050">
+                <a:solidFill>
+                  <a:srgbClr val="334155"/>
                 </a:solidFill>
               </a:defRPr>
             </a:pPr>
@@ -5455,18 +5545,18 @@
         </p:nvSpPr>
         <p:spPr>
           <a:xfrm>
-            <a:off x="731520" y="5074920"/>
-            <a:ext cx="4389120" cy="1051560"/>
+            <a:off x="731520" y="5166360"/>
+            <a:ext cx="4389120" cy="1097280"/>
           </a:xfrm>
           <a:prstGeom prst="roundRect">
             <a:avLst/>
           </a:prstGeom>
           <a:solidFill>
-            <a:srgbClr val="131C31"/>
+            <a:srgbClr val="FFFFFF"/>
           </a:solidFill>
           <a:ln w="12700">
             <a:solidFill>
-              <a:srgbClr val="334155"/>
+              <a:srgbClr val="CBD5E1"/>
             </a:solidFill>
           </a:ln>
         </p:spPr>
@@ -5500,8 +5590,8 @@
         </p:nvSpPr>
         <p:spPr>
           <a:xfrm>
-            <a:off x="914400" y="5166360"/>
-            <a:ext cx="4023360" cy="868680"/>
+            <a:off x="914400" y="5239512"/>
+            <a:ext cx="4023360" cy="914400"/>
           </a:xfrm>
           <a:prstGeom prst="rect">
             <a:avLst/>
@@ -5517,7 +5607,7 @@
             <a:pPr>
               <a:defRPr sz="1300" b="1">
                 <a:solidFill>
-                  <a:srgbClr val="F59E0B"/>
+                  <a:srgbClr val="D97706"/>
                 </a:solidFill>
               </a:defRPr>
             </a:pPr>
@@ -5527,21 +5617,66 @@
           </a:p>
           <a:p>
             <a:pPr>
-              <a:defRPr sz="1000">
-                <a:solidFill>
-                  <a:srgbClr val="94A3B8"/>
+              <a:defRPr sz="1050">
+                <a:solidFill>
+                  <a:srgbClr val="334155"/>
                 </a:solidFill>
               </a:defRPr>
             </a:pPr>
             <a:r>
               <a:t>Authoritative central trust store asynchronously logs tamper-evident trails.</a:t>
             </a:r>
+          </a:p>
+        </p:txBody>
+      </p:sp>
+      <p:sp>
+        <p:nvSpPr>
+          <p:cNvPr id="14" name="Rounded Rectangle 13"/>
+          <p:cNvSpPr/>
+          <p:nvPr/>
+        </p:nvSpPr>
+        <p:spPr>
+          <a:xfrm>
+            <a:off x="5349240" y="1554480"/>
+            <a:ext cx="6126480" cy="4846320"/>
+          </a:xfrm>
+          <a:prstGeom prst="roundRect">
+            <a:avLst/>
+          </a:prstGeom>
+          <a:solidFill>
+            <a:srgbClr val="FFFFFF"/>
+          </a:solidFill>
+          <a:ln w="12700">
+            <a:solidFill>
+              <a:srgbClr val="CBD5E1"/>
+            </a:solidFill>
+          </a:ln>
+        </p:spPr>
+        <p:style>
+          <a:lnRef idx="1">
+            <a:schemeClr val="accent1"/>
+          </a:lnRef>
+          <a:fillRef idx="3">
+            <a:schemeClr val="accent1"/>
+          </a:fillRef>
+          <a:effectRef idx="2">
+            <a:schemeClr val="accent1"/>
+          </a:effectRef>
+          <a:fontRef idx="minor">
+            <a:schemeClr val="lt1"/>
+          </a:fontRef>
+        </p:style>
+        <p:txBody>
+          <a:bodyPr rtlCol="0" anchor="ctr"/>
+          <a:lstStyle/>
+          <a:p>
+            <a:pPr algn="ctr"/>
           </a:p>
         </p:txBody>
       </p:sp>
       <p:pic>
         <p:nvPicPr>
-          <p:cNvPr id="14" name="Picture 13" descr="secops_console.png"/>
+          <p:cNvPr id="15" name="Picture 14" descr="secops_console.png"/>
           <p:cNvPicPr>
             <a:picLocks noChangeAspect="1"/>
           </p:cNvPicPr>
@@ -5555,8 +5690,8 @@
         </p:blipFill>
         <p:spPr>
           <a:xfrm>
-            <a:off x="5394960" y="1645920"/>
-            <a:ext cx="6035040" cy="4663440"/>
+            <a:off x="5394960" y="1600200"/>
+            <a:ext cx="6035040" cy="4754880"/>
           </a:xfrm>
           <a:prstGeom prst="rect">
             <a:avLst/>
@@ -5596,7 +5731,7 @@
             <a:avLst/>
           </a:prstGeom>
           <a:solidFill>
-            <a:srgbClr val="0B1120"/>
+            <a:srgbClr val="F8FAFC"/>
           </a:solidFill>
           <a:ln>
             <a:noFill/>
@@ -5633,7 +5768,7 @@
         <p:spPr>
           <a:xfrm>
             <a:off x="731520" y="365760"/>
-            <a:ext cx="10698480" cy="365760"/>
+            <a:ext cx="10698480" cy="320040"/>
           </a:xfrm>
           <a:prstGeom prst="rect">
             <a:avLst/>
@@ -5649,7 +5784,7 @@
             <a:pPr>
               <a:defRPr sz="1000" b="1">
                 <a:solidFill>
-                  <a:srgbClr val="10B981"/>
+                  <a:srgbClr val="059669"/>
                 </a:solidFill>
                 <a:latin typeface="Calibri"/>
               </a:defRPr>
@@ -5669,7 +5804,7 @@
         <p:spPr>
           <a:xfrm>
             <a:off x="731520" y="640080"/>
-            <a:ext cx="10698480" cy="548640"/>
+            <a:ext cx="10698480" cy="502920"/>
           </a:xfrm>
           <a:prstGeom prst="rect">
             <a:avLst/>
@@ -5685,7 +5820,7 @@
             <a:pPr>
               <a:defRPr sz="2200" b="1">
                 <a:solidFill>
-                  <a:srgbClr val="F8FAFC"/>
+                  <a:srgbClr val="0F172A"/>
                 </a:solidFill>
                 <a:latin typeface="Calibri"/>
               </a:defRPr>
@@ -5704,8 +5839,8 @@
         </p:nvSpPr>
         <p:spPr>
           <a:xfrm>
-            <a:off x="731520" y="1143000"/>
-            <a:ext cx="10698480" cy="365760"/>
+            <a:off x="731520" y="1115568"/>
+            <a:ext cx="10698480" cy="320040"/>
           </a:xfrm>
           <a:prstGeom prst="rect">
             <a:avLst/>
@@ -5719,9 +5854,9 @@
           <a:lstStyle/>
           <a:p>
             <a:pPr>
-              <a:defRPr sz="1200">
-                <a:solidFill>
-                  <a:srgbClr val="94A3B8"/>
+              <a:defRPr sz="1150">
+                <a:solidFill>
+                  <a:srgbClr val="64748B"/>
                 </a:solidFill>
                 <a:latin typeface="Calibri"/>
               </a:defRPr>
@@ -5740,18 +5875,18 @@
         </p:nvSpPr>
         <p:spPr>
           <a:xfrm>
-            <a:off x="731520" y="1645920"/>
-            <a:ext cx="4389120" cy="4663440"/>
+            <a:off x="731520" y="1600200"/>
+            <a:ext cx="4389120" cy="4754880"/>
           </a:xfrm>
           <a:prstGeom prst="roundRect">
             <a:avLst/>
           </a:prstGeom>
           <a:solidFill>
-            <a:srgbClr val="131C31"/>
+            <a:srgbClr val="FFFFFF"/>
           </a:solidFill>
           <a:ln w="12700">
             <a:solidFill>
-              <a:srgbClr val="334155"/>
+              <a:srgbClr val="CBD5E1"/>
             </a:solidFill>
           </a:ln>
         </p:spPr>
@@ -5785,8 +5920,8 @@
         </p:nvSpPr>
         <p:spPr>
           <a:xfrm>
-            <a:off x="914400" y="1828800"/>
-            <a:ext cx="4023360" cy="4297680"/>
+            <a:off x="914400" y="1783080"/>
+            <a:ext cx="4023360" cy="4389120"/>
           </a:xfrm>
           <a:prstGeom prst="rect">
             <a:avLst/>
@@ -5800,9 +5935,9 @@
           <a:lstStyle/>
           <a:p>
             <a:pPr>
-              <a:defRPr sz="1600" b="1">
-                <a:solidFill>
-                  <a:srgbClr val="F8FAFC"/>
+              <a:defRPr sz="1500" b="1">
+                <a:solidFill>
+                  <a:srgbClr val="0F172A"/>
                 </a:solidFill>
               </a:defRPr>
             </a:pPr>
@@ -5814,7 +5949,7 @@
             <a:pPr>
               <a:defRPr sz="1100">
                 <a:solidFill>
-                  <a:srgbClr val="94A3B8"/>
+                  <a:srgbClr val="334155"/>
                 </a:solidFill>
               </a:defRPr>
             </a:pPr>
@@ -5824,9 +5959,9 @@
           </a:p>
           <a:p>
             <a:pPr>
-              <a:defRPr sz="1300" b="1">
-                <a:solidFill>
-                  <a:srgbClr val="F59E0B"/>
+              <a:defRPr sz="1200" b="1">
+                <a:solidFill>
+                  <a:srgbClr val="D97706"/>
                 </a:solidFill>
               </a:defRPr>
             </a:pPr>
@@ -5838,7 +5973,7 @@
             <a:pPr>
               <a:defRPr b="1" sz="1100">
                 <a:solidFill>
-                  <a:srgbClr val="06B6D4"/>
+                  <a:srgbClr val="0284C7"/>
                 </a:solidFill>
               </a:defRPr>
             </a:pPr>
@@ -5850,7 +5985,7 @@
             <a:pPr>
               <a:defRPr sz="1000">
                 <a:solidFill>
-                  <a:srgbClr val="94A3B8"/>
+                  <a:srgbClr val="334155"/>
                 </a:solidFill>
               </a:defRPr>
             </a:pPr>
@@ -5862,7 +5997,7 @@
             <a:pPr>
               <a:defRPr b="1" sz="1100">
                 <a:solidFill>
-                  <a:srgbClr val="06B6D4"/>
+                  <a:srgbClr val="0284C7"/>
                 </a:solidFill>
               </a:defRPr>
             </a:pPr>
@@ -5874,7 +6009,7 @@
             <a:pPr>
               <a:defRPr sz="1000">
                 <a:solidFill>
-                  <a:srgbClr val="94A3B8"/>
+                  <a:srgbClr val="334155"/>
                 </a:solidFill>
               </a:defRPr>
             </a:pPr>
@@ -5886,7 +6021,7 @@
             <a:pPr>
               <a:defRPr b="1" sz="1100">
                 <a:solidFill>
-                  <a:srgbClr val="06B6D4"/>
+                  <a:srgbClr val="0284C7"/>
                 </a:solidFill>
               </a:defRPr>
             </a:pPr>
@@ -5898,19 +6033,64 @@
             <a:pPr>
               <a:defRPr sz="1000">
                 <a:solidFill>
-                  <a:srgbClr val="94A3B8"/>
+                  <a:srgbClr val="334155"/>
                 </a:solidFill>
               </a:defRPr>
             </a:pPr>
             <a:r>
               <a:t>Approved states receive an authoritative SHA-256 hash. The agent is promoted to COMMITTED prod status.</a:t>
             </a:r>
+          </a:p>
+        </p:txBody>
+      </p:sp>
+      <p:sp>
+        <p:nvSpPr>
+          <p:cNvPr id="8" name="Rounded Rectangle 7"/>
+          <p:cNvSpPr/>
+          <p:nvPr/>
+        </p:nvSpPr>
+        <p:spPr>
+          <a:xfrm>
+            <a:off x="5349240" y="1554480"/>
+            <a:ext cx="6126480" cy="4846320"/>
+          </a:xfrm>
+          <a:prstGeom prst="roundRect">
+            <a:avLst/>
+          </a:prstGeom>
+          <a:solidFill>
+            <a:srgbClr val="FFFFFF"/>
+          </a:solidFill>
+          <a:ln w="12700">
+            <a:solidFill>
+              <a:srgbClr val="CBD5E1"/>
+            </a:solidFill>
+          </a:ln>
+        </p:spPr>
+        <p:style>
+          <a:lnRef idx="1">
+            <a:schemeClr val="accent1"/>
+          </a:lnRef>
+          <a:fillRef idx="3">
+            <a:schemeClr val="accent1"/>
+          </a:fillRef>
+          <a:effectRef idx="2">
+            <a:schemeClr val="accent1"/>
+          </a:effectRef>
+          <a:fontRef idx="minor">
+            <a:schemeClr val="lt1"/>
+          </a:fontRef>
+        </p:style>
+        <p:txBody>
+          <a:bodyPr rtlCol="0" anchor="ctr"/>
+          <a:lstStyle/>
+          <a:p>
+            <a:pPr algn="ctr"/>
           </a:p>
         </p:txBody>
       </p:sp>
       <p:pic>
         <p:nvPicPr>
-          <p:cNvPr id="8" name="Picture 7" descr="state_timeline.png"/>
+          <p:cNvPr id="9" name="Picture 8" descr="state_timeline.png"/>
           <p:cNvPicPr>
             <a:picLocks noChangeAspect="1"/>
           </p:cNvPicPr>
@@ -5924,8 +6104,8 @@
         </p:blipFill>
         <p:spPr>
           <a:xfrm>
-            <a:off x="5394960" y="1645920"/>
-            <a:ext cx="6035040" cy="4663440"/>
+            <a:off x="5394960" y="1600200"/>
+            <a:ext cx="6035040" cy="4754880"/>
           </a:xfrm>
           <a:prstGeom prst="rect">
             <a:avLst/>
@@ -5965,7 +6145,7 @@
             <a:avLst/>
           </a:prstGeom>
           <a:solidFill>
-            <a:srgbClr val="0B1120"/>
+            <a:srgbClr val="F8FAFC"/>
           </a:solidFill>
           <a:ln>
             <a:noFill/>
@@ -6002,7 +6182,7 @@
         <p:spPr>
           <a:xfrm>
             <a:off x="731520" y="365760"/>
-            <a:ext cx="10698480" cy="365760"/>
+            <a:ext cx="10698480" cy="320040"/>
           </a:xfrm>
           <a:prstGeom prst="rect">
             <a:avLst/>
@@ -6018,7 +6198,7 @@
             <a:pPr>
               <a:defRPr sz="1000" b="1">
                 <a:solidFill>
-                  <a:srgbClr val="10B981"/>
+                  <a:srgbClr val="059669"/>
                 </a:solidFill>
                 <a:latin typeface="Calibri"/>
               </a:defRPr>
@@ -6038,7 +6218,7 @@
         <p:spPr>
           <a:xfrm>
             <a:off x="731520" y="640080"/>
-            <a:ext cx="10698480" cy="548640"/>
+            <a:ext cx="10698480" cy="502920"/>
           </a:xfrm>
           <a:prstGeom prst="rect">
             <a:avLst/>
@@ -6054,7 +6234,7 @@
             <a:pPr>
               <a:defRPr sz="2200" b="1">
                 <a:solidFill>
-                  <a:srgbClr val="F8FAFC"/>
+                  <a:srgbClr val="0F172A"/>
                 </a:solidFill>
                 <a:latin typeface="Calibri"/>
               </a:defRPr>
@@ -6073,8 +6253,8 @@
         </p:nvSpPr>
         <p:spPr>
           <a:xfrm>
-            <a:off x="731520" y="1143000"/>
-            <a:ext cx="10698480" cy="365760"/>
+            <a:off x="731520" y="1115568"/>
+            <a:ext cx="10698480" cy="320040"/>
           </a:xfrm>
           <a:prstGeom prst="rect">
             <a:avLst/>
@@ -6088,9 +6268,9 @@
           <a:lstStyle/>
           <a:p>
             <a:pPr>
-              <a:defRPr sz="1200">
-                <a:solidFill>
-                  <a:srgbClr val="94A3B8"/>
+              <a:defRPr sz="1150">
+                <a:solidFill>
+                  <a:srgbClr val="64748B"/>
                 </a:solidFill>
                 <a:latin typeface="Calibri"/>
               </a:defRPr>
@@ -6109,18 +6289,18 @@
         </p:nvSpPr>
         <p:spPr>
           <a:xfrm>
-            <a:off x="731520" y="1645920"/>
-            <a:ext cx="4389120" cy="4663440"/>
+            <a:off x="731520" y="1600200"/>
+            <a:ext cx="4389120" cy="4754880"/>
           </a:xfrm>
           <a:prstGeom prst="roundRect">
             <a:avLst/>
           </a:prstGeom>
           <a:solidFill>
-            <a:srgbClr val="131C31"/>
+            <a:srgbClr val="FEF2F2"/>
           </a:solidFill>
           <a:ln w="12700">
             <a:solidFill>
-              <a:srgbClr val="334155"/>
+              <a:srgbClr val="DC2626"/>
             </a:solidFill>
           </a:ln>
         </p:spPr>
@@ -6154,8 +6334,8 @@
         </p:nvSpPr>
         <p:spPr>
           <a:xfrm>
-            <a:off x="914400" y="1828800"/>
-            <a:ext cx="4023360" cy="4297680"/>
+            <a:off x="914400" y="1783080"/>
+            <a:ext cx="4023360" cy="4389120"/>
           </a:xfrm>
           <a:prstGeom prst="rect">
             <a:avLst/>
@@ -6169,9 +6349,9 @@
           <a:lstStyle/>
           <a:p>
             <a:pPr>
-              <a:defRPr sz="1600" b="1">
-                <a:solidFill>
-                  <a:srgbClr val="EF4444"/>
+              <a:defRPr sz="1500" b="1">
+                <a:solidFill>
+                  <a:srgbClr val="DC2626"/>
                 </a:solidFill>
               </a:defRPr>
             </a:pPr>
@@ -6183,7 +6363,7 @@
             <a:pPr>
               <a:defRPr b="1" sz="1100">
                 <a:solidFill>
-                  <a:srgbClr val="EF4444"/>
+                  <a:srgbClr val="DC2626"/>
                 </a:solidFill>
               </a:defRPr>
             </a:pPr>
@@ -6195,7 +6375,7 @@
             <a:pPr>
               <a:defRPr sz="1000">
                 <a:solidFill>
-                  <a:srgbClr val="94A3B8"/>
+                  <a:srgbClr val="334155"/>
                 </a:solidFill>
               </a:defRPr>
             </a:pPr>
@@ -6207,7 +6387,7 @@
             <a:pPr>
               <a:defRPr b="1" sz="1100">
                 <a:solidFill>
-                  <a:srgbClr val="EF4444"/>
+                  <a:srgbClr val="DC2626"/>
                 </a:solidFill>
               </a:defRPr>
             </a:pPr>
@@ -6219,7 +6399,7 @@
             <a:pPr>
               <a:defRPr sz="1000">
                 <a:solidFill>
-                  <a:srgbClr val="94A3B8"/>
+                  <a:srgbClr val="334155"/>
                 </a:solidFill>
               </a:defRPr>
             </a:pPr>
@@ -6231,7 +6411,7 @@
             <a:pPr>
               <a:defRPr b="1" sz="1100">
                 <a:solidFill>
-                  <a:srgbClr val="F59E0B"/>
+                  <a:srgbClr val="D97706"/>
                 </a:solidFill>
               </a:defRPr>
             </a:pPr>
@@ -6243,7 +6423,7 @@
             <a:pPr>
               <a:defRPr sz="1000">
                 <a:solidFill>
-                  <a:srgbClr val="94A3B8"/>
+                  <a:srgbClr val="334155"/>
                 </a:solidFill>
               </a:defRPr>
             </a:pPr>
@@ -6255,7 +6435,7 @@
             <a:pPr>
               <a:defRPr b="1" sz="1100">
                 <a:solidFill>
-                  <a:srgbClr val="10B981"/>
+                  <a:srgbClr val="059669"/>
                 </a:solidFill>
               </a:defRPr>
             </a:pPr>
@@ -6267,7 +6447,7 @@
             <a:pPr>
               <a:defRPr sz="1000">
                 <a:solidFill>
-                  <a:srgbClr val="94A3B8"/>
+                  <a:srgbClr val="334155"/>
                 </a:solidFill>
               </a:defRPr>
             </a:pPr>
@@ -6279,7 +6459,7 @@
             <a:pPr>
               <a:defRPr b="1" sz="1100">
                 <a:solidFill>
-                  <a:srgbClr val="10B981"/>
+                  <a:srgbClr val="059669"/>
                 </a:solidFill>
               </a:defRPr>
             </a:pPr>
@@ -6291,19 +6471,64 @@
             <a:pPr>
               <a:defRPr sz="1000">
                 <a:solidFill>
-                  <a:srgbClr val="94A3B8"/>
+                  <a:srgbClr val="334155"/>
                 </a:solidFill>
               </a:defRPr>
             </a:pPr>
             <a:r>
               <a:t>Security engineer or automated orchestrator restores certified checkpoint S101 with complete forensic trail.</a:t>
             </a:r>
+          </a:p>
+        </p:txBody>
+      </p:sp>
+      <p:sp>
+        <p:nvSpPr>
+          <p:cNvPr id="8" name="Rounded Rectangle 7"/>
+          <p:cNvSpPr/>
+          <p:nvPr/>
+        </p:nvSpPr>
+        <p:spPr>
+          <a:xfrm>
+            <a:off x="5349240" y="1554480"/>
+            <a:ext cx="6126480" cy="4846320"/>
+          </a:xfrm>
+          <a:prstGeom prst="roundRect">
+            <a:avLst/>
+          </a:prstGeom>
+          <a:solidFill>
+            <a:srgbClr val="FFFFFF"/>
+          </a:solidFill>
+          <a:ln w="12700">
+            <a:solidFill>
+              <a:srgbClr val="CBD5E1"/>
+            </a:solidFill>
+          </a:ln>
+        </p:spPr>
+        <p:style>
+          <a:lnRef idx="1">
+            <a:schemeClr val="accent1"/>
+          </a:lnRef>
+          <a:fillRef idx="3">
+            <a:schemeClr val="accent1"/>
+          </a:fillRef>
+          <a:effectRef idx="2">
+            <a:schemeClr val="accent1"/>
+          </a:effectRef>
+          <a:fontRef idx="minor">
+            <a:schemeClr val="lt1"/>
+          </a:fontRef>
+        </p:style>
+        <p:txBody>
+          <a:bodyPr rtlCol="0" anchor="ctr"/>
+          <a:lstStyle/>
+          <a:p>
+            <a:pPr algn="ctr"/>
           </a:p>
         </p:txBody>
       </p:sp>
       <p:pic>
         <p:nvPicPr>
-          <p:cNvPr id="8" name="Picture 7" descr="incident_forensics.png"/>
+          <p:cNvPr id="9" name="Picture 8" descr="incident_forensics.png"/>
           <p:cNvPicPr>
             <a:picLocks noChangeAspect="1"/>
           </p:cNvPicPr>
@@ -6317,8 +6542,8 @@
         </p:blipFill>
         <p:spPr>
           <a:xfrm>
-            <a:off x="5394960" y="1645920"/>
-            <a:ext cx="6035040" cy="4663440"/>
+            <a:off x="5394960" y="1600200"/>
+            <a:ext cx="6035040" cy="4754880"/>
           </a:xfrm>
           <a:prstGeom prst="rect">
             <a:avLst/>
@@ -6358,7 +6583,7 @@
             <a:avLst/>
           </a:prstGeom>
           <a:solidFill>
-            <a:srgbClr val="0B1120"/>
+            <a:srgbClr val="F8FAFC"/>
           </a:solidFill>
           <a:ln>
             <a:noFill/>
@@ -6395,7 +6620,7 @@
         <p:spPr>
           <a:xfrm>
             <a:off x="731520" y="365760"/>
-            <a:ext cx="10698480" cy="365760"/>
+            <a:ext cx="10698480" cy="320040"/>
           </a:xfrm>
           <a:prstGeom prst="rect">
             <a:avLst/>
@@ -6411,7 +6636,7 @@
             <a:pPr>
               <a:defRPr sz="1000" b="1">
                 <a:solidFill>
-                  <a:srgbClr val="10B981"/>
+                  <a:srgbClr val="059669"/>
                 </a:solidFill>
                 <a:latin typeface="Calibri"/>
               </a:defRPr>
@@ -6431,7 +6656,7 @@
         <p:spPr>
           <a:xfrm>
             <a:off x="731520" y="640080"/>
-            <a:ext cx="10698480" cy="548640"/>
+            <a:ext cx="10698480" cy="502920"/>
           </a:xfrm>
           <a:prstGeom prst="rect">
             <a:avLst/>
@@ -6447,7 +6672,7 @@
             <a:pPr>
               <a:defRPr sz="2200" b="1">
                 <a:solidFill>
-                  <a:srgbClr val="F8FAFC"/>
+                  <a:srgbClr val="0F172A"/>
                 </a:solidFill>
                 <a:latin typeface="Calibri"/>
               </a:defRPr>
@@ -6466,8 +6691,8 @@
         </p:nvSpPr>
         <p:spPr>
           <a:xfrm>
-            <a:off x="731520" y="1143000"/>
-            <a:ext cx="10698480" cy="365760"/>
+            <a:off x="731520" y="1115568"/>
+            <a:ext cx="10698480" cy="320040"/>
           </a:xfrm>
           <a:prstGeom prst="rect">
             <a:avLst/>
@@ -6481,9 +6706,9 @@
           <a:lstStyle/>
           <a:p>
             <a:pPr>
-              <a:defRPr sz="1200">
-                <a:solidFill>
-                  <a:srgbClr val="94A3B8"/>
+              <a:defRPr sz="1150">
+                <a:solidFill>
+                  <a:srgbClr val="64748B"/>
                 </a:solidFill>
                 <a:latin typeface="Calibri"/>
               </a:defRPr>
@@ -6502,18 +6727,18 @@
         </p:nvSpPr>
         <p:spPr>
           <a:xfrm>
-            <a:off x="731520" y="1645920"/>
-            <a:ext cx="3383280" cy="4663440"/>
+            <a:off x="731520" y="1600200"/>
+            <a:ext cx="3383280" cy="4754880"/>
           </a:xfrm>
           <a:prstGeom prst="roundRect">
             <a:avLst/>
           </a:prstGeom>
           <a:solidFill>
-            <a:srgbClr val="131C31"/>
+            <a:srgbClr val="FFFFFF"/>
           </a:solidFill>
           <a:ln w="12700">
             <a:solidFill>
-              <a:srgbClr val="06B6D4"/>
+              <a:srgbClr val="0284C7"/>
             </a:solidFill>
           </a:ln>
         </p:spPr>
@@ -6547,8 +6772,8 @@
         </p:nvSpPr>
         <p:spPr>
           <a:xfrm>
-            <a:off x="914400" y="1828800"/>
-            <a:ext cx="3017520" cy="4297680"/>
+            <a:off x="914400" y="1783080"/>
+            <a:ext cx="3017520" cy="4389120"/>
           </a:xfrm>
           <a:prstGeom prst="rect">
             <a:avLst/>
@@ -6562,9 +6787,9 @@
           <a:lstStyle/>
           <a:p>
             <a:pPr>
-              <a:defRPr sz="1400" b="1">
-                <a:solidFill>
-                  <a:srgbClr val="06B6D4"/>
+              <a:defRPr sz="1350" b="1">
+                <a:solidFill>
+                  <a:srgbClr val="0284C7"/>
                 </a:solidFill>
               </a:defRPr>
             </a:pPr>
@@ -6574,9 +6799,9 @@
           </a:p>
           <a:p>
             <a:pPr>
-              <a:defRPr sz="1000">
-                <a:solidFill>
-                  <a:srgbClr val="94A3B8"/>
+              <a:defRPr sz="1000" b="1">
+                <a:solidFill>
+                  <a:srgbClr val="64748B"/>
                 </a:solidFill>
               </a:defRPr>
             </a:pPr>
@@ -6588,7 +6813,7 @@
             <a:pPr>
               <a:defRPr sz="1050">
                 <a:solidFill>
-                  <a:srgbClr val="F8FAFC"/>
+                  <a:srgbClr val="334155"/>
                 </a:solidFill>
               </a:defRPr>
             </a:pPr>
@@ -6600,7 +6825,7 @@
             <a:pPr>
               <a:defRPr sz="1050">
                 <a:solidFill>
-                  <a:srgbClr val="F8FAFC"/>
+                  <a:srgbClr val="334155"/>
                 </a:solidFill>
               </a:defRPr>
             </a:pPr>
@@ -6612,7 +6837,7 @@
             <a:pPr>
               <a:defRPr sz="1050">
                 <a:solidFill>
-                  <a:srgbClr val="F8FAFC"/>
+                  <a:srgbClr val="334155"/>
                 </a:solidFill>
               </a:defRPr>
             </a:pPr>
@@ -6630,18 +6855,18 @@
         </p:nvSpPr>
         <p:spPr>
           <a:xfrm>
-            <a:off x="4389120" y="1645920"/>
-            <a:ext cx="3383280" cy="4663440"/>
+            <a:off x="4389120" y="1600200"/>
+            <a:ext cx="3383280" cy="4754880"/>
           </a:xfrm>
           <a:prstGeom prst="roundRect">
             <a:avLst/>
           </a:prstGeom>
           <a:solidFill>
-            <a:srgbClr val="131C31"/>
+            <a:srgbClr val="FFFFFF"/>
           </a:solidFill>
           <a:ln w="12700">
             <a:solidFill>
-              <a:srgbClr val="10B981"/>
+              <a:srgbClr val="059669"/>
             </a:solidFill>
           </a:ln>
         </p:spPr>
@@ -6675,8 +6900,8 @@
         </p:nvSpPr>
         <p:spPr>
           <a:xfrm>
-            <a:off x="4572000" y="1828800"/>
-            <a:ext cx="3017520" cy="4297680"/>
+            <a:off x="4572000" y="1783080"/>
+            <a:ext cx="3017520" cy="4389120"/>
           </a:xfrm>
           <a:prstGeom prst="rect">
             <a:avLst/>
@@ -6690,9 +6915,9 @@
           <a:lstStyle/>
           <a:p>
             <a:pPr>
-              <a:defRPr sz="1400" b="1">
-                <a:solidFill>
-                  <a:srgbClr val="10B981"/>
+              <a:defRPr sz="1350" b="1">
+                <a:solidFill>
+                  <a:srgbClr val="059669"/>
                 </a:solidFill>
               </a:defRPr>
             </a:pPr>
@@ -6702,9 +6927,9 @@
           </a:p>
           <a:p>
             <a:pPr>
-              <a:defRPr sz="1000">
-                <a:solidFill>
-                  <a:srgbClr val="94A3B8"/>
+              <a:defRPr sz="1000" b="1">
+                <a:solidFill>
+                  <a:srgbClr val="64748B"/>
                 </a:solidFill>
               </a:defRPr>
             </a:pPr>
@@ -6716,7 +6941,7 @@
             <a:pPr>
               <a:defRPr sz="1050">
                 <a:solidFill>
-                  <a:srgbClr val="F8FAFC"/>
+                  <a:srgbClr val="334155"/>
                 </a:solidFill>
               </a:defRPr>
             </a:pPr>
@@ -6728,7 +6953,7 @@
             <a:pPr>
               <a:defRPr sz="1050">
                 <a:solidFill>
-                  <a:srgbClr val="F8FAFC"/>
+                  <a:srgbClr val="334155"/>
                 </a:solidFill>
               </a:defRPr>
             </a:pPr>
@@ -6740,7 +6965,7 @@
             <a:pPr>
               <a:defRPr sz="1050">
                 <a:solidFill>
-                  <a:srgbClr val="F8FAFC"/>
+                  <a:srgbClr val="334155"/>
                 </a:solidFill>
               </a:defRPr>
             </a:pPr>
@@ -6752,7 +6977,7 @@
             <a:pPr>
               <a:defRPr sz="1050">
                 <a:solidFill>
-                  <a:srgbClr val="F8FAFC"/>
+                  <a:srgbClr val="334155"/>
                 </a:solidFill>
               </a:defRPr>
             </a:pPr>
@@ -6770,18 +6995,18 @@
         </p:nvSpPr>
         <p:spPr>
           <a:xfrm>
-            <a:off x="8046720" y="1645920"/>
-            <a:ext cx="3383280" cy="4663440"/>
+            <a:off x="8046720" y="1600200"/>
+            <a:ext cx="3383280" cy="4754880"/>
           </a:xfrm>
           <a:prstGeom prst="roundRect">
             <a:avLst/>
           </a:prstGeom>
           <a:solidFill>
-            <a:srgbClr val="131C31"/>
+            <a:srgbClr val="FFFFFF"/>
           </a:solidFill>
           <a:ln w="12700">
             <a:solidFill>
-              <a:srgbClr val="6366F1"/>
+              <a:srgbClr val="4F46E5"/>
             </a:solidFill>
           </a:ln>
         </p:spPr>
@@ -6815,8 +7040,8 @@
         </p:nvSpPr>
         <p:spPr>
           <a:xfrm>
-            <a:off x="8229600" y="1828800"/>
-            <a:ext cx="3017520" cy="4297680"/>
+            <a:off x="8229600" y="1783080"/>
+            <a:ext cx="3017520" cy="4389120"/>
           </a:xfrm>
           <a:prstGeom prst="rect">
             <a:avLst/>
@@ -6830,9 +7055,9 @@
           <a:lstStyle/>
           <a:p>
             <a:pPr>
-              <a:defRPr sz="1400" b="1">
-                <a:solidFill>
-                  <a:srgbClr val="6366F1"/>
+              <a:defRPr sz="1350" b="1">
+                <a:solidFill>
+                  <a:srgbClr val="4F46E5"/>
                 </a:solidFill>
               </a:defRPr>
             </a:pPr>
@@ -6842,9 +7067,9 @@
           </a:p>
           <a:p>
             <a:pPr>
-              <a:defRPr sz="1000">
-                <a:solidFill>
-                  <a:srgbClr val="94A3B8"/>
+              <a:defRPr sz="1000" b="1">
+                <a:solidFill>
+                  <a:srgbClr val="64748B"/>
                 </a:solidFill>
               </a:defRPr>
             </a:pPr>
@@ -6856,7 +7081,7 @@
             <a:pPr>
               <a:defRPr sz="1050">
                 <a:solidFill>
-                  <a:srgbClr val="F8FAFC"/>
+                  <a:srgbClr val="334155"/>
                 </a:solidFill>
               </a:defRPr>
             </a:pPr>
@@ -6868,7 +7093,7 @@
             <a:pPr>
               <a:defRPr sz="1050">
                 <a:solidFill>
-                  <a:srgbClr val="F8FAFC"/>
+                  <a:srgbClr val="334155"/>
                 </a:solidFill>
               </a:defRPr>
             </a:pPr>
@@ -6880,7 +7105,7 @@
             <a:pPr>
               <a:defRPr sz="1050">
                 <a:solidFill>
-                  <a:srgbClr val="F8FAFC"/>
+                  <a:srgbClr val="334155"/>
                 </a:solidFill>
               </a:defRPr>
             </a:pPr>
@@ -6892,7 +7117,7 @@
             <a:pPr>
               <a:defRPr sz="1050">
                 <a:solidFill>
-                  <a:srgbClr val="F8FAFC"/>
+                  <a:srgbClr val="334155"/>
                 </a:solidFill>
               </a:defRPr>
             </a:pPr>
@@ -6904,7 +7129,7 @@
             <a:pPr>
               <a:defRPr sz="1050">
                 <a:solidFill>
-                  <a:srgbClr val="F8FAFC"/>
+                  <a:srgbClr val="334155"/>
                 </a:solidFill>
               </a:defRPr>
             </a:pPr>

</xml_diff>

<commit_message>
feat: design and integrate catchy enterprise cybersecurity logo mark across navbar, hero, modals, presentation deck, and favicons
</commit_message>
<xml_diff>
--- a/TrustState_Executive_Presentation.pptx
+++ b/TrustState_Executive_Presentation.pptx
@@ -3218,16 +3218,40 @@
           </a:p>
         </p:txBody>
       </p:sp>
-      <p:sp>
-        <p:nvSpPr>
-          <p:cNvPr id="5" name="TextBox 4"/>
+      <p:pic>
+        <p:nvPicPr>
+          <p:cNvPr id="5" name="Picture 4" descr="truststate-logo.png"/>
+          <p:cNvPicPr>
+            <a:picLocks noChangeAspect="1"/>
+          </p:cNvPicPr>
+          <p:nvPr/>
+        </p:nvPicPr>
+        <p:blipFill>
+          <a:blip r:embed="rId2"/>
+          <a:stretch>
+            <a:fillRect/>
+          </a:stretch>
+        </p:blipFill>
+        <p:spPr>
+          <a:xfrm>
+            <a:off x="731520" y="1325880"/>
+            <a:ext cx="822960" cy="822960"/>
+          </a:xfrm>
+          <a:prstGeom prst="rect">
+            <a:avLst/>
+          </a:prstGeom>
+        </p:spPr>
+      </p:pic>
+      <p:sp>
+        <p:nvSpPr>
+          <p:cNvPr id="6" name="TextBox 5"/>
           <p:cNvSpPr txBox="1"/>
           <p:nvPr/>
         </p:nvSpPr>
         <p:spPr>
           <a:xfrm>
-            <a:off x="731520" y="1280160"/>
-            <a:ext cx="6217920" cy="1005840"/>
+            <a:off x="1691640" y="1234440"/>
+            <a:ext cx="5303520" cy="1005840"/>
           </a:xfrm>
           <a:prstGeom prst="rect">
             <a:avLst/>
@@ -3255,7 +3279,7 @@
       </p:sp>
       <p:sp>
         <p:nvSpPr>
-          <p:cNvPr id="6" name="TextBox 5"/>
+          <p:cNvPr id="7" name="TextBox 6"/>
           <p:cNvSpPr txBox="1"/>
           <p:nvPr/>
         </p:nvSpPr>
@@ -3302,7 +3326,7 @@
       </p:sp>
       <p:sp>
         <p:nvSpPr>
-          <p:cNvPr id="7" name="TextBox 6"/>
+          <p:cNvPr id="8" name="TextBox 7"/>
           <p:cNvSpPr txBox="1"/>
           <p:nvPr/>
         </p:nvSpPr>
@@ -3337,7 +3361,7 @@
       </p:sp>
       <p:sp>
         <p:nvSpPr>
-          <p:cNvPr id="8" name="Rounded Rectangle 7"/>
+          <p:cNvPr id="9" name="Rounded Rectangle 8"/>
           <p:cNvSpPr/>
           <p:nvPr/>
         </p:nvSpPr>
@@ -3382,7 +3406,7 @@
       </p:sp>
       <p:sp>
         <p:nvSpPr>
-          <p:cNvPr id="9" name="TextBox 8"/>
+          <p:cNvPr id="10" name="TextBox 9"/>
           <p:cNvSpPr txBox="1"/>
           <p:nvPr/>
         </p:nvSpPr>
@@ -3441,7 +3465,7 @@
       </p:sp>
       <p:sp>
         <p:nvSpPr>
-          <p:cNvPr id="10" name="Rounded Rectangle 9"/>
+          <p:cNvPr id="11" name="Rounded Rectangle 10"/>
           <p:cNvSpPr/>
           <p:nvPr/>
         </p:nvSpPr>
@@ -3486,14 +3510,14 @@
       </p:sp>
       <p:pic>
         <p:nvPicPr>
-          <p:cNvPr id="11" name="Picture 10" descr="hero_landing.png"/>
+          <p:cNvPr id="12" name="Picture 11" descr="hero_landing.png"/>
           <p:cNvPicPr>
             <a:picLocks noChangeAspect="1"/>
           </p:cNvPicPr>
           <p:nvPr/>
         </p:nvPicPr>
         <p:blipFill>
-          <a:blip r:embed="rId2"/>
+          <a:blip r:embed="rId3"/>
           <a:stretch>
             <a:fillRect/>
           </a:stretch>
@@ -3677,9 +3701,33 @@
           </a:p>
         </p:txBody>
       </p:sp>
-      <p:sp>
-        <p:nvSpPr>
-          <p:cNvPr id="6" name="Rounded Rectangle 5"/>
+      <p:pic>
+        <p:nvPicPr>
+          <p:cNvPr id="6" name="Picture 5" descr="truststate-logo.png"/>
+          <p:cNvPicPr>
+            <a:picLocks noChangeAspect="1"/>
+          </p:cNvPicPr>
+          <p:nvPr/>
+        </p:nvPicPr>
+        <p:blipFill>
+          <a:blip r:embed="rId2"/>
+          <a:stretch>
+            <a:fillRect/>
+          </a:stretch>
+        </p:blipFill>
+        <p:spPr>
+          <a:xfrm>
+            <a:off x="10972800" y="365760"/>
+            <a:ext cx="502920" cy="502920"/>
+          </a:xfrm>
+          <a:prstGeom prst="rect">
+            <a:avLst/>
+          </a:prstGeom>
+        </p:spPr>
+      </p:pic>
+      <p:sp>
+        <p:nvSpPr>
+          <p:cNvPr id="7" name="Rounded Rectangle 6"/>
           <p:cNvSpPr/>
           <p:nvPr/>
         </p:nvSpPr>
@@ -3724,7 +3772,7 @@
       </p:sp>
       <p:sp>
         <p:nvSpPr>
-          <p:cNvPr id="7" name="TextBox 6"/>
+          <p:cNvPr id="8" name="TextBox 7"/>
           <p:cNvSpPr txBox="1"/>
           <p:nvPr/>
         </p:nvSpPr>
@@ -3839,7 +3887,7 @@
       </p:sp>
       <p:sp>
         <p:nvSpPr>
-          <p:cNvPr id="8" name="Rounded Rectangle 7"/>
+          <p:cNvPr id="9" name="Rounded Rectangle 8"/>
           <p:cNvSpPr/>
           <p:nvPr/>
         </p:nvSpPr>
@@ -3884,7 +3932,7 @@
       </p:sp>
       <p:sp>
         <p:nvSpPr>
-          <p:cNvPr id="9" name="TextBox 8"/>
+          <p:cNvPr id="10" name="TextBox 9"/>
           <p:cNvSpPr txBox="1"/>
           <p:nvPr/>
         </p:nvSpPr>
@@ -3999,7 +4047,7 @@
       </p:sp>
       <p:sp>
         <p:nvSpPr>
-          <p:cNvPr id="10" name="Rounded Rectangle 9"/>
+          <p:cNvPr id="11" name="Rounded Rectangle 10"/>
           <p:cNvSpPr/>
           <p:nvPr/>
         </p:nvSpPr>
@@ -4044,7 +4092,7 @@
       </p:sp>
       <p:sp>
         <p:nvSpPr>
-          <p:cNvPr id="11" name="TextBox 10"/>
+          <p:cNvPr id="12" name="TextBox 11"/>
           <p:cNvSpPr txBox="1"/>
           <p:nvPr/>
         </p:nvSpPr>
@@ -4246,9 +4294,33 @@
           </a:p>
         </p:txBody>
       </p:sp>
-      <p:sp>
-        <p:nvSpPr>
-          <p:cNvPr id="6" name="Rounded Rectangle 5"/>
+      <p:pic>
+        <p:nvPicPr>
+          <p:cNvPr id="6" name="Picture 5" descr="truststate-logo.png"/>
+          <p:cNvPicPr>
+            <a:picLocks noChangeAspect="1"/>
+          </p:cNvPicPr>
+          <p:nvPr/>
+        </p:nvPicPr>
+        <p:blipFill>
+          <a:blip r:embed="rId2"/>
+          <a:stretch>
+            <a:fillRect/>
+          </a:stretch>
+        </p:blipFill>
+        <p:spPr>
+          <a:xfrm>
+            <a:off x="10972800" y="365760"/>
+            <a:ext cx="502920" cy="502920"/>
+          </a:xfrm>
+          <a:prstGeom prst="rect">
+            <a:avLst/>
+          </a:prstGeom>
+        </p:spPr>
+      </p:pic>
+      <p:sp>
+        <p:nvSpPr>
+          <p:cNvPr id="7" name="Rounded Rectangle 6"/>
           <p:cNvSpPr/>
           <p:nvPr/>
         </p:nvSpPr>
@@ -4293,7 +4365,7 @@
       </p:sp>
       <p:sp>
         <p:nvSpPr>
-          <p:cNvPr id="7" name="TextBox 6"/>
+          <p:cNvPr id="8" name="TextBox 7"/>
           <p:cNvSpPr txBox="1"/>
           <p:nvPr/>
         </p:nvSpPr>
@@ -4400,7 +4472,7 @@
       </p:sp>
       <p:sp>
         <p:nvSpPr>
-          <p:cNvPr id="8" name="Rounded Rectangle 7"/>
+          <p:cNvPr id="9" name="Rounded Rectangle 8"/>
           <p:cNvSpPr/>
           <p:nvPr/>
         </p:nvSpPr>
@@ -4445,7 +4517,7 @@
       </p:sp>
       <p:sp>
         <p:nvSpPr>
-          <p:cNvPr id="9" name="TextBox 8"/>
+          <p:cNvPr id="10" name="TextBox 9"/>
           <p:cNvSpPr txBox="1"/>
           <p:nvPr/>
         </p:nvSpPr>
@@ -4552,7 +4624,7 @@
       </p:sp>
       <p:sp>
         <p:nvSpPr>
-          <p:cNvPr id="10" name="Rounded Rectangle 9"/>
+          <p:cNvPr id="11" name="Rounded Rectangle 10"/>
           <p:cNvSpPr/>
           <p:nvPr/>
         </p:nvSpPr>
@@ -4597,7 +4669,7 @@
       </p:sp>
       <p:sp>
         <p:nvSpPr>
-          <p:cNvPr id="11" name="TextBox 10"/>
+          <p:cNvPr id="12" name="TextBox 11"/>
           <p:cNvSpPr txBox="1"/>
           <p:nvPr/>
         </p:nvSpPr>
@@ -4871,9 +4943,33 @@
           </a:p>
         </p:txBody>
       </p:sp>
-      <p:sp>
-        <p:nvSpPr>
-          <p:cNvPr id="6" name="Rounded Rectangle 5"/>
+      <p:pic>
+        <p:nvPicPr>
+          <p:cNvPr id="6" name="Picture 5" descr="truststate-logo.png"/>
+          <p:cNvPicPr>
+            <a:picLocks noChangeAspect="1"/>
+          </p:cNvPicPr>
+          <p:nvPr/>
+        </p:nvPicPr>
+        <p:blipFill>
+          <a:blip r:embed="rId2"/>
+          <a:stretch>
+            <a:fillRect/>
+          </a:stretch>
+        </p:blipFill>
+        <p:spPr>
+          <a:xfrm>
+            <a:off x="10972800" y="365760"/>
+            <a:ext cx="502920" cy="502920"/>
+          </a:xfrm>
+          <a:prstGeom prst="rect">
+            <a:avLst/>
+          </a:prstGeom>
+        </p:spPr>
+      </p:pic>
+      <p:sp>
+        <p:nvSpPr>
+          <p:cNvPr id="7" name="Rounded Rectangle 6"/>
           <p:cNvSpPr/>
           <p:nvPr/>
         </p:nvSpPr>
@@ -4918,7 +5014,7 @@
       </p:sp>
       <p:sp>
         <p:nvSpPr>
-          <p:cNvPr id="7" name="TextBox 6"/>
+          <p:cNvPr id="8" name="TextBox 7"/>
           <p:cNvSpPr txBox="1"/>
           <p:nvPr/>
         </p:nvSpPr>
@@ -5025,7 +5121,7 @@
       </p:sp>
       <p:sp>
         <p:nvSpPr>
-          <p:cNvPr id="8" name="Rounded Rectangle 7"/>
+          <p:cNvPr id="9" name="Rounded Rectangle 8"/>
           <p:cNvSpPr/>
           <p:nvPr/>
         </p:nvSpPr>
@@ -5070,14 +5166,14 @@
       </p:sp>
       <p:pic>
         <p:nvPicPr>
-          <p:cNvPr id="9" name="Picture 8" descr="architecture_diagram.png"/>
+          <p:cNvPr id="10" name="Picture 9" descr="architecture_diagram.png"/>
           <p:cNvPicPr>
             <a:picLocks noChangeAspect="1"/>
           </p:cNvPicPr>
           <p:nvPr/>
         </p:nvPicPr>
         <p:blipFill>
-          <a:blip r:embed="rId2"/>
+          <a:blip r:embed="rId3"/>
           <a:stretch>
             <a:fillRect/>
           </a:stretch>
@@ -5261,9 +5357,33 @@
           </a:p>
         </p:txBody>
       </p:sp>
-      <p:sp>
-        <p:nvSpPr>
-          <p:cNvPr id="6" name="Rounded Rectangle 5"/>
+      <p:pic>
+        <p:nvPicPr>
+          <p:cNvPr id="6" name="Picture 5" descr="truststate-logo.png"/>
+          <p:cNvPicPr>
+            <a:picLocks noChangeAspect="1"/>
+          </p:cNvPicPr>
+          <p:nvPr/>
+        </p:nvPicPr>
+        <p:blipFill>
+          <a:blip r:embed="rId2"/>
+          <a:stretch>
+            <a:fillRect/>
+          </a:stretch>
+        </p:blipFill>
+        <p:spPr>
+          <a:xfrm>
+            <a:off x="10972800" y="365760"/>
+            <a:ext cx="502920" cy="502920"/>
+          </a:xfrm>
+          <a:prstGeom prst="rect">
+            <a:avLst/>
+          </a:prstGeom>
+        </p:spPr>
+      </p:pic>
+      <p:sp>
+        <p:nvSpPr>
+          <p:cNvPr id="7" name="Rounded Rectangle 6"/>
           <p:cNvSpPr/>
           <p:nvPr/>
         </p:nvSpPr>
@@ -5308,7 +5428,7 @@
       </p:sp>
       <p:sp>
         <p:nvSpPr>
-          <p:cNvPr id="7" name="TextBox 6"/>
+          <p:cNvPr id="8" name="TextBox 7"/>
           <p:cNvSpPr txBox="1"/>
           <p:nvPr/>
         </p:nvSpPr>
@@ -5355,7 +5475,7 @@
       </p:sp>
       <p:sp>
         <p:nvSpPr>
-          <p:cNvPr id="8" name="Rounded Rectangle 7"/>
+          <p:cNvPr id="9" name="Rounded Rectangle 8"/>
           <p:cNvSpPr/>
           <p:nvPr/>
         </p:nvSpPr>
@@ -5400,7 +5520,7 @@
       </p:sp>
       <p:sp>
         <p:nvSpPr>
-          <p:cNvPr id="9" name="TextBox 8"/>
+          <p:cNvPr id="10" name="TextBox 9"/>
           <p:cNvSpPr txBox="1"/>
           <p:nvPr/>
         </p:nvSpPr>
@@ -5447,7 +5567,7 @@
       </p:sp>
       <p:sp>
         <p:nvSpPr>
-          <p:cNvPr id="10" name="Rounded Rectangle 9"/>
+          <p:cNvPr id="11" name="Rounded Rectangle 10"/>
           <p:cNvSpPr/>
           <p:nvPr/>
         </p:nvSpPr>
@@ -5492,7 +5612,7 @@
       </p:sp>
       <p:sp>
         <p:nvSpPr>
-          <p:cNvPr id="11" name="TextBox 10"/>
+          <p:cNvPr id="12" name="TextBox 11"/>
           <p:cNvSpPr txBox="1"/>
           <p:nvPr/>
         </p:nvSpPr>
@@ -5539,7 +5659,7 @@
       </p:sp>
       <p:sp>
         <p:nvSpPr>
-          <p:cNvPr id="12" name="Rounded Rectangle 11"/>
+          <p:cNvPr id="13" name="Rounded Rectangle 12"/>
           <p:cNvSpPr/>
           <p:nvPr/>
         </p:nvSpPr>
@@ -5584,7 +5704,7 @@
       </p:sp>
       <p:sp>
         <p:nvSpPr>
-          <p:cNvPr id="13" name="TextBox 12"/>
+          <p:cNvPr id="14" name="TextBox 13"/>
           <p:cNvSpPr txBox="1"/>
           <p:nvPr/>
         </p:nvSpPr>
@@ -5631,7 +5751,7 @@
       </p:sp>
       <p:sp>
         <p:nvSpPr>
-          <p:cNvPr id="14" name="Rounded Rectangle 13"/>
+          <p:cNvPr id="15" name="Rounded Rectangle 14"/>
           <p:cNvSpPr/>
           <p:nvPr/>
         </p:nvSpPr>
@@ -5676,14 +5796,14 @@
       </p:sp>
       <p:pic>
         <p:nvPicPr>
-          <p:cNvPr id="15" name="Picture 14" descr="secops_console.png"/>
+          <p:cNvPr id="16" name="Picture 15" descr="secops_console.png"/>
           <p:cNvPicPr>
             <a:picLocks noChangeAspect="1"/>
           </p:cNvPicPr>
           <p:nvPr/>
         </p:nvPicPr>
         <p:blipFill>
-          <a:blip r:embed="rId2"/>
+          <a:blip r:embed="rId3"/>
           <a:stretch>
             <a:fillRect/>
           </a:stretch>
@@ -5867,9 +5987,33 @@
           </a:p>
         </p:txBody>
       </p:sp>
-      <p:sp>
-        <p:nvSpPr>
-          <p:cNvPr id="6" name="Rounded Rectangle 5"/>
+      <p:pic>
+        <p:nvPicPr>
+          <p:cNvPr id="6" name="Picture 5" descr="truststate-logo.png"/>
+          <p:cNvPicPr>
+            <a:picLocks noChangeAspect="1"/>
+          </p:cNvPicPr>
+          <p:nvPr/>
+        </p:nvPicPr>
+        <p:blipFill>
+          <a:blip r:embed="rId2"/>
+          <a:stretch>
+            <a:fillRect/>
+          </a:stretch>
+        </p:blipFill>
+        <p:spPr>
+          <a:xfrm>
+            <a:off x="10972800" y="365760"/>
+            <a:ext cx="502920" cy="502920"/>
+          </a:xfrm>
+          <a:prstGeom prst="rect">
+            <a:avLst/>
+          </a:prstGeom>
+        </p:spPr>
+      </p:pic>
+      <p:sp>
+        <p:nvSpPr>
+          <p:cNvPr id="7" name="Rounded Rectangle 6"/>
           <p:cNvSpPr/>
           <p:nvPr/>
         </p:nvSpPr>
@@ -5914,7 +6058,7 @@
       </p:sp>
       <p:sp>
         <p:nvSpPr>
-          <p:cNvPr id="7" name="TextBox 6"/>
+          <p:cNvPr id="8" name="TextBox 7"/>
           <p:cNvSpPr txBox="1"/>
           <p:nvPr/>
         </p:nvSpPr>
@@ -6045,7 +6189,7 @@
       </p:sp>
       <p:sp>
         <p:nvSpPr>
-          <p:cNvPr id="8" name="Rounded Rectangle 7"/>
+          <p:cNvPr id="9" name="Rounded Rectangle 8"/>
           <p:cNvSpPr/>
           <p:nvPr/>
         </p:nvSpPr>
@@ -6090,14 +6234,14 @@
       </p:sp>
       <p:pic>
         <p:nvPicPr>
-          <p:cNvPr id="9" name="Picture 8" descr="state_timeline.png"/>
+          <p:cNvPr id="10" name="Picture 9" descr="state_timeline.png"/>
           <p:cNvPicPr>
             <a:picLocks noChangeAspect="1"/>
           </p:cNvPicPr>
           <p:nvPr/>
         </p:nvPicPr>
         <p:blipFill>
-          <a:blip r:embed="rId2"/>
+          <a:blip r:embed="rId3"/>
           <a:stretch>
             <a:fillRect/>
           </a:stretch>
@@ -6281,9 +6425,33 @@
           </a:p>
         </p:txBody>
       </p:sp>
-      <p:sp>
-        <p:nvSpPr>
-          <p:cNvPr id="6" name="Rounded Rectangle 5"/>
+      <p:pic>
+        <p:nvPicPr>
+          <p:cNvPr id="6" name="Picture 5" descr="truststate-logo.png"/>
+          <p:cNvPicPr>
+            <a:picLocks noChangeAspect="1"/>
+          </p:cNvPicPr>
+          <p:nvPr/>
+        </p:nvPicPr>
+        <p:blipFill>
+          <a:blip r:embed="rId2"/>
+          <a:stretch>
+            <a:fillRect/>
+          </a:stretch>
+        </p:blipFill>
+        <p:spPr>
+          <a:xfrm>
+            <a:off x="10972800" y="365760"/>
+            <a:ext cx="502920" cy="502920"/>
+          </a:xfrm>
+          <a:prstGeom prst="rect">
+            <a:avLst/>
+          </a:prstGeom>
+        </p:spPr>
+      </p:pic>
+      <p:sp>
+        <p:nvSpPr>
+          <p:cNvPr id="7" name="Rounded Rectangle 6"/>
           <p:cNvSpPr/>
           <p:nvPr/>
         </p:nvSpPr>
@@ -6328,7 +6496,7 @@
       </p:sp>
       <p:sp>
         <p:nvSpPr>
-          <p:cNvPr id="7" name="TextBox 6"/>
+          <p:cNvPr id="8" name="TextBox 7"/>
           <p:cNvSpPr txBox="1"/>
           <p:nvPr/>
         </p:nvSpPr>
@@ -6483,7 +6651,7 @@
       </p:sp>
       <p:sp>
         <p:nvSpPr>
-          <p:cNvPr id="8" name="Rounded Rectangle 7"/>
+          <p:cNvPr id="9" name="Rounded Rectangle 8"/>
           <p:cNvSpPr/>
           <p:nvPr/>
         </p:nvSpPr>
@@ -6528,14 +6696,14 @@
       </p:sp>
       <p:pic>
         <p:nvPicPr>
-          <p:cNvPr id="9" name="Picture 8" descr="incident_forensics.png"/>
+          <p:cNvPr id="10" name="Picture 9" descr="incident_forensics.png"/>
           <p:cNvPicPr>
             <a:picLocks noChangeAspect="1"/>
           </p:cNvPicPr>
           <p:nvPr/>
         </p:nvPicPr>
         <p:blipFill>
-          <a:blip r:embed="rId2"/>
+          <a:blip r:embed="rId3"/>
           <a:stretch>
             <a:fillRect/>
           </a:stretch>
@@ -6719,9 +6887,33 @@
           </a:p>
         </p:txBody>
       </p:sp>
-      <p:sp>
-        <p:nvSpPr>
-          <p:cNvPr id="6" name="Rounded Rectangle 5"/>
+      <p:pic>
+        <p:nvPicPr>
+          <p:cNvPr id="6" name="Picture 5" descr="truststate-logo.png"/>
+          <p:cNvPicPr>
+            <a:picLocks noChangeAspect="1"/>
+          </p:cNvPicPr>
+          <p:nvPr/>
+        </p:nvPicPr>
+        <p:blipFill>
+          <a:blip r:embed="rId2"/>
+          <a:stretch>
+            <a:fillRect/>
+          </a:stretch>
+        </p:blipFill>
+        <p:spPr>
+          <a:xfrm>
+            <a:off x="10972800" y="365760"/>
+            <a:ext cx="502920" cy="502920"/>
+          </a:xfrm>
+          <a:prstGeom prst="rect">
+            <a:avLst/>
+          </a:prstGeom>
+        </p:spPr>
+      </p:pic>
+      <p:sp>
+        <p:nvSpPr>
+          <p:cNvPr id="7" name="Rounded Rectangle 6"/>
           <p:cNvSpPr/>
           <p:nvPr/>
         </p:nvSpPr>
@@ -6766,7 +6958,7 @@
       </p:sp>
       <p:sp>
         <p:nvSpPr>
-          <p:cNvPr id="7" name="TextBox 6"/>
+          <p:cNvPr id="8" name="TextBox 7"/>
           <p:cNvSpPr txBox="1"/>
           <p:nvPr/>
         </p:nvSpPr>
@@ -6849,7 +7041,7 @@
       </p:sp>
       <p:sp>
         <p:nvSpPr>
-          <p:cNvPr id="8" name="Rounded Rectangle 7"/>
+          <p:cNvPr id="9" name="Rounded Rectangle 8"/>
           <p:cNvSpPr/>
           <p:nvPr/>
         </p:nvSpPr>
@@ -6894,7 +7086,7 @@
       </p:sp>
       <p:sp>
         <p:nvSpPr>
-          <p:cNvPr id="9" name="TextBox 8"/>
+          <p:cNvPr id="10" name="TextBox 9"/>
           <p:cNvSpPr txBox="1"/>
           <p:nvPr/>
         </p:nvSpPr>
@@ -6989,7 +7181,7 @@
       </p:sp>
       <p:sp>
         <p:nvSpPr>
-          <p:cNvPr id="10" name="Rounded Rectangle 9"/>
+          <p:cNvPr id="11" name="Rounded Rectangle 10"/>
           <p:cNvSpPr/>
           <p:nvPr/>
         </p:nvSpPr>
@@ -7034,7 +7226,7 @@
       </p:sp>
       <p:sp>
         <p:nvSpPr>
-          <p:cNvPr id="11" name="TextBox 10"/>
+          <p:cNvPr id="12" name="TextBox 11"/>
           <p:cNvSpPr txBox="1"/>
           <p:nvPr/>
         </p:nvSpPr>

</xml_diff>